<commit_message>
Email final Z.ai (autoridade+visão compartilhada+4ª vertical proptech); PPTX atualizado com PropTech ★ GLM Flash
</commit_message>
<xml_diff>
--- a/apresentacoes/ZCloud-Zai-Parceria-EN.pptx
+++ b/apresentacoes/ZCloud-Zai-Parceria-EN.pptx
@@ -5882,7 +5882,7 @@
                 <a:ea typeface="Helvetica Neue" pitchFamily="34" charset="-122"/>
                 <a:cs typeface="Helvetica Neue" pitchFamily="34" charset="-120"/>
               </a:rPr>
-              <a:t>6</a:t>
+              <a:t>4</a:t>
             </a:r>
             <a:endParaRPr lang="en-US" sz="2200" dirty="0"/>
           </a:p>
@@ -6088,7 +6088,7 @@
                 <a:ea typeface="Helvetica Neue" pitchFamily="34" charset="-122"/>
                 <a:cs typeface="Helvetica Neue" pitchFamily="34" charset="-120"/>
               </a:rPr>
-              <a:t>1.75M</a:t>
+              <a:t>1.75M+</a:t>
             </a:r>
             <a:endParaRPr lang="en-US" sz="2200" dirty="0"/>
           </a:p>
@@ -12916,7 +12916,7 @@
                   <a:srgbClr val="0A1628"/>
                 </a:solidFill>
               </a:rPr>
-              <a:t>LegalTech</a:t>
+              <a:t>HealthTech</a:t>
             </a:r>
             <a:endParaRPr lang="en-US" sz="1500" dirty="0"/>
           </a:p>
@@ -12936,7 +12936,7 @@
                   <a:srgbClr val="2E6FAF"/>
                 </a:solidFill>
               </a:rPr>
-              <a:t>ragjur.ai</a:t>
+              <a:t>dodr.ai · ragmed.ai</a:t>
             </a:r>
             <a:endParaRPr lang="en-US" sz="1500" dirty="0"/>
           </a:p>
@@ -12976,7 +12976,7 @@
                   <a:srgbClr val="5A6B7A"/>
                 </a:solidFill>
               </a:rPr>
-              <a:t>67M+ court decisions indexed · 55 sources · GLM-5.3 integration mapped</a:t>
+              <a:t>8 portals live · 6 frontier models · anti-hallucination chain · clinical decision support</a:t>
             </a:r>
             <a:endParaRPr lang="en-US" sz="1500" dirty="0"/>
           </a:p>
@@ -13016,7 +13016,7 @@
                   <a:srgbClr val="B0342C"/>
                 </a:solidFill>
               </a:rPr>
-              <a:t>1.2M attorneys · R$ 80B/yr</a:t>
+              <a:t>550k physicians · R$ 4.4B/yr</a:t>
             </a:r>
             <a:endParaRPr lang="en-US" sz="1500" dirty="0"/>
           </a:p>
@@ -13083,7 +13083,7 @@
                   <a:srgbClr val="0A1628"/>
                 </a:solidFill>
               </a:rPr>
-              <a:t>HealthTech</a:t>
+              <a:t>LegalTech</a:t>
             </a:r>
             <a:endParaRPr lang="en-US" sz="1500" dirty="0"/>
           </a:p>
@@ -13103,7 +13103,7 @@
                   <a:srgbClr val="2E6FAF"/>
                 </a:solidFill>
               </a:rPr>
-              <a:t>dodr.ai · ragmed.ai</a:t>
+              <a:t>ragjur.ai</a:t>
             </a:r>
             <a:endParaRPr lang="en-US" sz="1500" dirty="0"/>
           </a:p>
@@ -13143,7 +13143,7 @@
                   <a:srgbClr val="5A6B7A"/>
                 </a:solidFill>
               </a:rPr>
-              <a:t>8 portals live · 6 frontier models · anti-hallucination chain · clinical decision support</a:t>
+              <a:t>67M+ court decisions indexed · 55 sources · GLM-5.3 for analysis, Flash for volume search</a:t>
             </a:r>
             <a:endParaRPr lang="en-US" sz="1500" dirty="0"/>
           </a:p>
@@ -13183,7 +13183,7 @@
                   <a:srgbClr val="B0342C"/>
                 </a:solidFill>
               </a:rPr>
-              <a:t>550k physicians · R$ 4.4B/yr</a:t>
+              <a:t>1.2M attorneys · R$ 80B/yr</a:t>
             </a:r>
             <a:endParaRPr lang="en-US" sz="1500" dirty="0"/>
           </a:p>
@@ -13310,7 +13310,7 @@
                   <a:srgbClr val="5A6B7A"/>
                 </a:solidFill>
               </a:rPr>
-              <a:t>AML compliance, SAR narrative, KYC · GLM-5.3 for analysis, Flash for volume</a:t>
+              <a:t>AML compliance, SAR narrative, KYC · GLM-5.3 for deep analysis, Flash for triage</a:t>
             </a:r>
             <a:endParaRPr lang="en-US" sz="1500" dirty="0"/>
           </a:p>
@@ -13417,7 +13417,7 @@
                   <a:srgbClr val="E8C847"/>
                 </a:solidFill>
               </a:rPr>
-              <a:t>Marketplace</a:t>
+              <a:t>PropTech ★ GLM Flash</a:t>
             </a:r>
             <a:endParaRPr lang="en-US" sz="1500" dirty="0"/>
           </a:p>
@@ -13437,7 +13437,7 @@
                   <a:srgbClr val="8FB0C8"/>
                 </a:solidFill>
               </a:rPr>
-              <a:t>ativo.tech · z.cloud</a:t>
+              <a:t>alirealty.com.br · cyrela.ai</a:t>
             </a:r>
             <a:endParaRPr lang="en-US" sz="1500" dirty="0"/>
           </a:p>
@@ -13477,7 +13477,7 @@
                   <a:srgbClr val="B0C4D4"/>
                 </a:solidFill>
               </a:rPr>
-              <a:t>Cloud &amp; AI marketplace in production · z.cloud pilot as sovereign token cloud</a:t>
+              <a:t>Document analysis, credit triage, due diligence · GLM-5.3 Flash processes in seconds what takes hours</a:t>
             </a:r>
             <a:endParaRPr lang="en-US" sz="1500" dirty="0"/>
           </a:p>
@@ -13517,7 +13517,7 @@
                   <a:srgbClr val="E8C847"/>
                 </a:solidFill>
               </a:rPr>
-              <a:t>Global · US$ 11.9M/yr projected</a:t>
+              <a:t>R$ 15B/yr (real estate tech)</a:t>
             </a:r>
             <a:endParaRPr lang="en-US" sz="1500" dirty="0"/>
           </a:p>

</xml_diff>

<commit_message>
Data center as revenue multiplier: compute-as-a-service, LATAM, compute bottleneck, colocation; revenue updated to US$943M/5yr (3.1× ROI, 10.7× EV)
</commit_message>
<xml_diff>
--- a/apresentacoes/ZCloud-Zai-Parceria-EN.pptx
+++ b/apresentacoes/ZCloud-Zai-Parceria-EN.pptx
@@ -17,9 +17,10 @@
     <p:sldId id="265" r:id="rId11"/>
     <p:sldId id="266" r:id="rId12"/>
     <p:sldId id="267" r:id="rId13"/>
+    <p:sldId id="268" r:id="rId14"/>
   </p:sldIdLst>
   <p:notesMasterIdLst>
-    <p:notesMasterId r:id="rId14"/>
+    <p:notesMasterId r:id="rId15"/>
   </p:notesMasterIdLst>
   <p:sldSz cx="12188952" cy="6858000"/>
   <p:notesSz cx="6858000" cy="12188952"/>
@@ -596,16 +597,16 @@
                   <c:v>14.2</c:v>
                 </c:pt>
                 <c:pt idx="1">
-                  <c:v>55</c:v>
+                  <c:v>62</c:v>
                 </c:pt>
                 <c:pt idx="2">
-                  <c:v>108</c:v>
+                  <c:v>142</c:v>
                 </c:pt>
                 <c:pt idx="3">
-                  <c:v>187</c:v>
+                  <c:v>268</c:v>
                 </c:pt>
                 <c:pt idx="4">
-                  <c:v>279</c:v>
+                  <c:v>420</c:v>
                 </c:pt>
               </c:numCache>
             </c:numRef>
@@ -1470,6 +1471,94 @@
             <a:fld id="{F7021451-1387-4CA6-816F-3879F97B5CBC}" type="slidenum">
               <a:rPr lang="en-US"/>
               <a:t>12</a:t>
+            </a:fld>
+            <a:endParaRPr lang="en-US"/>
+          </a:p>
+        </p:txBody>
+      </p:sp>
+    </p:spTree>
+    <p:extLst>
+      <p:ext uri="{BB962C8B-B14F-4D97-AF65-F5344CB8AC3E}">
+        <p14:creationId xmlns:p14="http://schemas.microsoft.com/office/powerpoint/2010/main" val="1024086991"/>
+      </p:ext>
+    </p:extLst>
+  </p:cSld>
+  <p:clrMapOvr>
+    <a:masterClrMapping/>
+  </p:clrMapOvr>
+</p:notes>
+</file>
+
+<file path=ppt/notesSlides/notesSlide13.xml><?xml version="1.0" encoding="utf-8"?>
+<p:notes xmlns:a="http://schemas.openxmlformats.org/drawingml/2006/main" xmlns:r="http://schemas.openxmlformats.org/officeDocument/2006/relationships" xmlns:p="http://schemas.openxmlformats.org/presentationml/2006/main">
+  <p:cSld>
+    <p:spTree>
+      <p:nvGrpSpPr>
+        <p:cNvPr id="1" name=""/>
+        <p:cNvGrpSpPr/>
+        <p:nvPr/>
+      </p:nvGrpSpPr>
+      <p:grpSpPr>
+        <a:xfrm>
+          <a:off x="0" y="0"/>
+          <a:ext cx="0" cy="0"/>
+          <a:chOff x="0" y="0"/>
+          <a:chExt cx="0" cy="0"/>
+        </a:xfrm>
+      </p:grpSpPr>
+      <p:sp>
+        <p:nvSpPr>
+          <p:cNvPr id="2" name="Slide Image Placeholder 1"/>
+          <p:cNvSpPr>
+            <a:spLocks noGrp="1" noRot="1" noChangeAspect="1"/>
+          </p:cNvSpPr>
+          <p:nvPr>
+            <p:ph type="sldImg"/>
+          </p:nvPr>
+        </p:nvSpPr>
+        <p:spPr/>
+      </p:sp>
+      <p:sp>
+        <p:nvSpPr>
+          <p:cNvPr id="3" name="Notes Placeholder 2"/>
+          <p:cNvSpPr>
+            <a:spLocks noGrp="1"/>
+          </p:cNvSpPr>
+          <p:nvPr>
+            <p:ph type="body" idx="1"/>
+          </p:nvPr>
+        </p:nvSpPr>
+        <p:spPr/>
+        <p:txBody>
+          <a:bodyPr/>
+          <a:lstStyle/>
+          <a:p>
+            <a:r>
+              <a:rPr lang="en-US" dirty="0"/>
+              <a:t/>
+            </a:r>
+            <a:endParaRPr lang="en-US" dirty="0"/>
+          </a:p>
+        </p:txBody>
+      </p:sp>
+      <p:sp>
+        <p:nvSpPr>
+          <p:cNvPr id="4" name="Slide Number Placeholder 3"/>
+          <p:cNvSpPr>
+            <a:spLocks noGrp="1"/>
+          </p:cNvSpPr>
+          <p:nvPr>
+            <p:ph type="sldNum" sz="quarter" idx="10"/>
+          </p:nvPr>
+        </p:nvSpPr>
+        <p:spPr/>
+        <p:txBody>
+          <a:bodyPr/>
+          <a:lstStyle/>
+          <a:p>
+            <a:fld id="{F7021451-1387-4CA6-816F-3879F97B5CBC}" type="slidenum">
+              <a:rPr lang="en-US"/>
+              <a:t>13</a:t>
             </a:fld>
             <a:endParaRPr lang="en-US"/>
           </a:p>
@@ -3057,6 +3146,862 @@
     <p:bg>
       <p:bgPr>
         <a:solidFill>
+          <a:srgbClr val="FFFFFF"/>
+        </a:solidFill>
+      </p:bgPr>
+    </p:bg>
+    <p:spTree>
+      <p:nvGrpSpPr>
+        <p:cNvPr id="1" name=""/>
+        <p:cNvGrpSpPr/>
+        <p:nvPr/>
+      </p:nvGrpSpPr>
+      <p:grpSpPr>
+        <a:xfrm>
+          <a:off x="0" y="0"/>
+          <a:ext cx="0" cy="0"/>
+          <a:chOff x="0" y="0"/>
+          <a:chExt cx="0" cy="0"/>
+        </a:xfrm>
+      </p:grpSpPr>
+      <p:sp>
+        <p:nvSpPr>
+          <p:cNvPr id="2" name="Text 0"/>
+          <p:cNvSpPr/>
+          <p:nvPr/>
+        </p:nvSpPr>
+        <p:spPr>
+          <a:xfrm>
+            <a:off x="502920" y="320040"/>
+            <a:ext cx="11183112" cy="640080"/>
+          </a:xfrm>
+          <a:prstGeom prst="rect">
+            <a:avLst/>
+          </a:prstGeom>
+          <a:noFill/>
+          <a:ln/>
+        </p:spPr>
+        <p:txBody>
+          <a:bodyPr wrap="square" lIns="0" tIns="0" rIns="0" bIns="0" rtlCol="0" anchor="ctr"/>
+          <a:lstStyle/>
+          <a:p>
+            <a:pPr indent="0" marL="0">
+              <a:buNone/>
+            </a:pPr>
+            <a:r>
+              <a:rPr lang="en-US" sz="3000" b="1" dirty="0">
+                <a:solidFill>
+                  <a:srgbClr val="0A1628"/>
+                </a:solidFill>
+                <a:latin typeface="Helvetica Neue" pitchFamily="34" charset="0"/>
+                <a:ea typeface="Helvetica Neue" pitchFamily="34" charset="-122"/>
+                <a:cs typeface="Helvetica Neue" pitchFamily="34" charset="-120"/>
+              </a:rPr>
+              <a:t>The Data Center: Not Just Infrastructure — A Revenue Multiplier</a:t>
+            </a:r>
+            <a:endParaRPr lang="en-US" sz="3000" dirty="0"/>
+          </a:p>
+        </p:txBody>
+      </p:sp>
+      <p:sp>
+        <p:nvSpPr>
+          <p:cNvPr id="3" name="Text 1"/>
+          <p:cNvSpPr/>
+          <p:nvPr/>
+        </p:nvSpPr>
+        <p:spPr>
+          <a:xfrm>
+            <a:off x="502920" y="914400"/>
+            <a:ext cx="11183112" cy="365760"/>
+          </a:xfrm>
+          <a:prstGeom prst="rect">
+            <a:avLst/>
+          </a:prstGeom>
+          <a:noFill/>
+          <a:ln/>
+        </p:spPr>
+        <p:txBody>
+          <a:bodyPr wrap="square" lIns="0" tIns="0" rIns="0" bIns="0" rtlCol="0" anchor="ctr"/>
+          <a:lstStyle/>
+          <a:p>
+            <a:pPr indent="0" marL="0">
+              <a:buNone/>
+            </a:pPr>
+            <a:r>
+              <a:rPr lang="en-US" sz="1300" dirty="0">
+                <a:solidFill>
+                  <a:srgbClr val="5A6B7A"/>
+                </a:solidFill>
+                <a:latin typeface="Helvetica Neue" pitchFamily="34" charset="0"/>
+                <a:ea typeface="Helvetica Neue" pitchFamily="34" charset="-122"/>
+                <a:cs typeface="Helvetica Neue" pitchFamily="34" charset="-120"/>
+              </a:rPr>
+              <a:t>Compute as a service, LATAM presence, and the elimination of the exhaust bottleneck</a:t>
+            </a:r>
+            <a:endParaRPr lang="en-US" sz="1300" dirty="0"/>
+          </a:p>
+        </p:txBody>
+      </p:sp>
+      <p:sp>
+        <p:nvSpPr>
+          <p:cNvPr id="4" name="Shape 2"/>
+          <p:cNvSpPr/>
+          <p:nvPr/>
+        </p:nvSpPr>
+        <p:spPr>
+          <a:xfrm>
+            <a:off x="502920" y="1298448"/>
+            <a:ext cx="2194560" cy="0"/>
+          </a:xfrm>
+          <a:prstGeom prst="line">
+            <a:avLst/>
+          </a:prstGeom>
+          <a:noFill/>
+          <a:ln w="38100">
+            <a:solidFill>
+              <a:srgbClr val="C9A227"/>
+            </a:solidFill>
+            <a:prstDash val="solid"/>
+          </a:ln>
+        </p:spPr>
+      </p:sp>
+      <p:sp>
+        <p:nvSpPr>
+          <p:cNvPr id="5" name="Text 3"/>
+          <p:cNvSpPr/>
+          <p:nvPr/>
+        </p:nvSpPr>
+        <p:spPr>
+          <a:xfrm>
+            <a:off x="502920" y="1463040"/>
+            <a:ext cx="5486400" cy="365760"/>
+          </a:xfrm>
+          <a:prstGeom prst="rect">
+            <a:avLst/>
+          </a:prstGeom>
+          <a:noFill/>
+          <a:ln/>
+        </p:spPr>
+        <p:txBody>
+          <a:bodyPr wrap="square" lIns="0" tIns="0" rIns="0" bIns="0" rtlCol="0" anchor="ctr"/>
+          <a:lstStyle/>
+          <a:p>
+            <a:pPr indent="0" marL="0">
+              <a:buNone/>
+            </a:pPr>
+            <a:r>
+              <a:rPr lang="en-US" sz="1300" b="1" dirty="0">
+                <a:solidFill>
+                  <a:srgbClr val="0A1628"/>
+                </a:solidFill>
+                <a:latin typeface="Helvetica Neue" pitchFamily="34" charset="0"/>
+                <a:ea typeface="Helvetica Neue" pitchFamily="34" charset="-122"/>
+                <a:cs typeface="Helvetica Neue" pitchFamily="34" charset="-120"/>
+              </a:rPr>
+              <a:t>Three Revenue Streams from the Data Center</a:t>
+            </a:r>
+            <a:endParaRPr lang="en-US" sz="1300" dirty="0"/>
+          </a:p>
+        </p:txBody>
+      </p:sp>
+      <p:sp>
+        <p:nvSpPr>
+          <p:cNvPr id="6" name="Shape 4"/>
+          <p:cNvSpPr/>
+          <p:nvPr/>
+        </p:nvSpPr>
+        <p:spPr>
+          <a:xfrm>
+            <a:off x="502920" y="1874520"/>
+            <a:ext cx="5394960" cy="1280160"/>
+          </a:xfrm>
+          <a:prstGeom prst="rect">
+            <a:avLst/>
+          </a:prstGeom>
+          <a:solidFill>
+            <a:srgbClr val="0A1628"/>
+          </a:solidFill>
+          <a:ln w="19050">
+            <a:solidFill>
+              <a:srgbClr val="C9A227"/>
+            </a:solidFill>
+            <a:prstDash val="solid"/>
+          </a:ln>
+        </p:spPr>
+      </p:sp>
+      <p:sp>
+        <p:nvSpPr>
+          <p:cNvPr id="7" name="Text 5"/>
+          <p:cNvSpPr/>
+          <p:nvPr/>
+        </p:nvSpPr>
+        <p:spPr>
+          <a:xfrm>
+            <a:off x="731520" y="1965960"/>
+            <a:ext cx="4937760" cy="1097280"/>
+          </a:xfrm>
+          <a:prstGeom prst="rect">
+            <a:avLst/>
+          </a:prstGeom>
+          <a:noFill/>
+          <a:ln/>
+        </p:spPr>
+        <p:txBody>
+          <a:bodyPr wrap="square" lIns="0" tIns="0" rIns="0" bIns="0" rtlCol="0" anchor="ctr"/>
+          <a:lstStyle/>
+          <a:p>
+            <a:pPr indent="0" marL="0">
+              <a:lnSpc>
+                <a:spcPts val="1100"/>
+              </a:lnSpc>
+              <a:spcAft>
+                <a:spcPts val="300"/>
+              </a:spcAft>
+              <a:buNone/>
+            </a:pPr>
+            <a:r>
+              <a:rPr lang="en-US" sz="1100" b="1" dirty="0">
+                <a:solidFill>
+                  <a:srgbClr val="E8C847"/>
+                </a:solidFill>
+              </a:rPr>
+              <a:t>1. Compute-as-a-Service (GPU Cloud)</a:t>
+            </a:r>
+            <a:endParaRPr lang="en-US" sz="1100" dirty="0"/>
+          </a:p>
+          <a:p>
+            <a:pPr indent="0" marL="0">
+              <a:lnSpc>
+                <a:spcPts val="1100"/>
+              </a:lnSpc>
+              <a:spcAft>
+                <a:spcPts val="300"/>
+              </a:spcAft>
+              <a:buNone/>
+            </a:pPr>
+            <a:r>
+              <a:rPr lang="en-US" sz="850" dirty="0">
+                <a:solidFill>
+                  <a:srgbClr val="B0C4D4"/>
+                </a:solidFill>
+              </a:rPr>
+              <a:t>Renting GPU capacity to AI companies, research institutions, and startups across LATAM. The same L20/H100 infrastructure that serves our models serves external clients during off-peak.</a:t>
+            </a:r>
+            <a:endParaRPr lang="en-US" sz="1100" dirty="0"/>
+          </a:p>
+          <a:p>
+            <a:pPr indent="0" marL="0">
+              <a:lnSpc>
+                <a:spcPts val="1100"/>
+              </a:lnSpc>
+              <a:spcAft>
+                <a:spcPts val="300"/>
+              </a:spcAft>
+              <a:buNone/>
+            </a:pPr>
+            <a:r>
+              <a:rPr lang="en-US" sz="1000" b="1" dirty="0">
+                <a:solidFill>
+                  <a:srgbClr val="E8C847"/>
+                </a:solidFill>
+              </a:rPr>
+              <a:t>US$ 45M/yr (Year 5)</a:t>
+            </a:r>
+            <a:endParaRPr lang="en-US" sz="1100" dirty="0"/>
+          </a:p>
+        </p:txBody>
+      </p:sp>
+      <p:sp>
+        <p:nvSpPr>
+          <p:cNvPr id="8" name="Shape 6"/>
+          <p:cNvSpPr/>
+          <p:nvPr/>
+        </p:nvSpPr>
+        <p:spPr>
+          <a:xfrm>
+            <a:off x="502920" y="3291840"/>
+            <a:ext cx="5394960" cy="1280160"/>
+          </a:xfrm>
+          <a:prstGeom prst="rect">
+            <a:avLst/>
+          </a:prstGeom>
+          <a:solidFill>
+            <a:srgbClr val="F0F4F7"/>
+          </a:solidFill>
+          <a:ln w="9525">
+            <a:solidFill>
+              <a:srgbClr val="C8D2DA"/>
+            </a:solidFill>
+            <a:prstDash val="solid"/>
+          </a:ln>
+        </p:spPr>
+      </p:sp>
+      <p:sp>
+        <p:nvSpPr>
+          <p:cNvPr id="9" name="Text 7"/>
+          <p:cNvSpPr/>
+          <p:nvPr/>
+        </p:nvSpPr>
+        <p:spPr>
+          <a:xfrm>
+            <a:off x="731520" y="3383280"/>
+            <a:ext cx="4937760" cy="1097280"/>
+          </a:xfrm>
+          <a:prstGeom prst="rect">
+            <a:avLst/>
+          </a:prstGeom>
+          <a:noFill/>
+          <a:ln/>
+        </p:spPr>
+        <p:txBody>
+          <a:bodyPr wrap="square" lIns="0" tIns="0" rIns="0" bIns="0" rtlCol="0" anchor="ctr"/>
+          <a:lstStyle/>
+          <a:p>
+            <a:pPr indent="0" marL="0">
+              <a:lnSpc>
+                <a:spcPts val="1100"/>
+              </a:lnSpc>
+              <a:spcAft>
+                <a:spcPts val="300"/>
+              </a:spcAft>
+              <a:buNone/>
+            </a:pPr>
+            <a:r>
+              <a:rPr lang="en-US" sz="1100" b="1" dirty="0">
+                <a:solidFill>
+                  <a:srgbClr val="0A1628"/>
+                </a:solidFill>
+              </a:rPr>
+              <a:t>2. Sovereign Cloud (z.cloud API)</a:t>
+            </a:r>
+            <a:endParaRPr lang="en-US" sz="1100" dirty="0"/>
+          </a:p>
+          <a:p>
+            <a:pPr indent="0" marL="0">
+              <a:lnSpc>
+                <a:spcPts val="1100"/>
+              </a:lnSpc>
+              <a:spcAft>
+                <a:spcPts val="300"/>
+              </a:spcAft>
+              <a:buNone/>
+            </a:pPr>
+            <a:r>
+              <a:rPr lang="en-US" sz="850" dirty="0">
+                <a:solidFill>
+                  <a:srgbClr val="5A6B7A"/>
+                </a:solidFill>
+              </a:rPr>
+              <a:t>Token-based API for regulated institutions that need GLM running in Brazilian territory. Financial, healthcare, legal — 1.75M+ professionals in Brazil alone.</a:t>
+            </a:r>
+            <a:endParaRPr lang="en-US" sz="1100" dirty="0"/>
+          </a:p>
+          <a:p>
+            <a:pPr indent="0" marL="0">
+              <a:lnSpc>
+                <a:spcPts val="1100"/>
+              </a:lnSpc>
+              <a:spcAft>
+                <a:spcPts val="300"/>
+              </a:spcAft>
+              <a:buNone/>
+            </a:pPr>
+            <a:r>
+              <a:rPr lang="en-US" sz="1000" b="1" dirty="0">
+                <a:solidFill>
+                  <a:srgbClr val="B0342C"/>
+                </a:solidFill>
+              </a:rPr>
+              <a:t>US$ 60M/yr (Year 5)</a:t>
+            </a:r>
+            <a:endParaRPr lang="en-US" sz="1100" dirty="0"/>
+          </a:p>
+        </p:txBody>
+      </p:sp>
+      <p:sp>
+        <p:nvSpPr>
+          <p:cNvPr id="10" name="Shape 8"/>
+          <p:cNvSpPr/>
+          <p:nvPr/>
+        </p:nvSpPr>
+        <p:spPr>
+          <a:xfrm>
+            <a:off x="502920" y="4709160"/>
+            <a:ext cx="5394960" cy="1280160"/>
+          </a:xfrm>
+          <a:prstGeom prst="rect">
+            <a:avLst/>
+          </a:prstGeom>
+          <a:solidFill>
+            <a:srgbClr val="F0F4F7"/>
+          </a:solidFill>
+          <a:ln w="9525">
+            <a:solidFill>
+              <a:srgbClr val="C8D2DA"/>
+            </a:solidFill>
+            <a:prstDash val="solid"/>
+          </a:ln>
+        </p:spPr>
+      </p:sp>
+      <p:sp>
+        <p:nvSpPr>
+          <p:cNvPr id="11" name="Text 9"/>
+          <p:cNvSpPr/>
+          <p:nvPr/>
+        </p:nvSpPr>
+        <p:spPr>
+          <a:xfrm>
+            <a:off x="731520" y="4800600"/>
+            <a:ext cx="4937760" cy="1097280"/>
+          </a:xfrm>
+          <a:prstGeom prst="rect">
+            <a:avLst/>
+          </a:prstGeom>
+          <a:noFill/>
+          <a:ln/>
+        </p:spPr>
+        <p:txBody>
+          <a:bodyPr wrap="square" lIns="0" tIns="0" rIns="0" bIns="0" rtlCol="0" anchor="ctr"/>
+          <a:lstStyle/>
+          <a:p>
+            <a:pPr indent="0" marL="0">
+              <a:lnSpc>
+                <a:spcPts val="1100"/>
+              </a:lnSpc>
+              <a:spcAft>
+                <a:spcPts val="300"/>
+              </a:spcAft>
+              <a:buNone/>
+            </a:pPr>
+            <a:r>
+              <a:rPr lang="en-US" sz="1100" b="1" dirty="0">
+                <a:solidFill>
+                  <a:srgbClr val="0A1628"/>
+                </a:solidFill>
+              </a:rPr>
+              <a:t>3. Data Center Colocation (ZPE CE)</a:t>
+            </a:r>
+            <a:endParaRPr lang="en-US" sz="1100" dirty="0"/>
+          </a:p>
+          <a:p>
+            <a:pPr indent="0" marL="0">
+              <a:lnSpc>
+                <a:spcPts val="1100"/>
+              </a:lnSpc>
+              <a:spcAft>
+                <a:spcPts val="300"/>
+              </a:spcAft>
+              <a:buNone/>
+            </a:pPr>
+            <a:r>
+              <a:rPr lang="en-US" sz="850" dirty="0">
+                <a:solidFill>
+                  <a:srgbClr val="5A6B7A"/>
+                </a:solidFill>
+              </a:rPr>
+              <a:t>Rack space in the ZPE for companies needing Brazilian jurisdiction with submarine cable access. Same model as TikTok's Brazilian DC.</a:t>
+            </a:r>
+            <a:endParaRPr lang="en-US" sz="1100" dirty="0"/>
+          </a:p>
+          <a:p>
+            <a:pPr indent="0" marL="0">
+              <a:lnSpc>
+                <a:spcPts val="1100"/>
+              </a:lnSpc>
+              <a:spcAft>
+                <a:spcPts val="300"/>
+              </a:spcAft>
+              <a:buNone/>
+            </a:pPr>
+            <a:r>
+              <a:rPr lang="en-US" sz="1000" b="1" dirty="0">
+                <a:solidFill>
+                  <a:srgbClr val="B0342C"/>
+                </a:solidFill>
+              </a:rPr>
+              <a:t>US$ 25M/yr (Year 5)</a:t>
+            </a:r>
+            <a:endParaRPr lang="en-US" sz="1100" dirty="0"/>
+          </a:p>
+        </p:txBody>
+      </p:sp>
+      <p:sp>
+        <p:nvSpPr>
+          <p:cNvPr id="12" name="Text 10"/>
+          <p:cNvSpPr/>
+          <p:nvPr/>
+        </p:nvSpPr>
+        <p:spPr>
+          <a:xfrm>
+            <a:off x="6400800" y="1463040"/>
+            <a:ext cx="5303520" cy="365760"/>
+          </a:xfrm>
+          <a:prstGeom prst="rect">
+            <a:avLst/>
+          </a:prstGeom>
+          <a:noFill/>
+          <a:ln/>
+        </p:spPr>
+        <p:txBody>
+          <a:bodyPr wrap="square" lIns="0" tIns="0" rIns="0" bIns="0" rtlCol="0" anchor="ctr"/>
+          <a:lstStyle/>
+          <a:p>
+            <a:pPr indent="0" marL="0">
+              <a:buNone/>
+            </a:pPr>
+            <a:r>
+              <a:rPr lang="en-US" sz="1300" b="1" dirty="0">
+                <a:solidFill>
+                  <a:srgbClr val="0A1628"/>
+                </a:solidFill>
+                <a:latin typeface="Helvetica Neue" pitchFamily="34" charset="0"/>
+                <a:ea typeface="Helvetica Neue" pitchFamily="34" charset="-122"/>
+                <a:cs typeface="Helvetica Neue" pitchFamily="34" charset="-120"/>
+              </a:rPr>
+              <a:t>Why the Return Is Far Greater Than It Appears</a:t>
+            </a:r>
+            <a:endParaRPr lang="en-US" sz="1300" dirty="0"/>
+          </a:p>
+        </p:txBody>
+      </p:sp>
+      <p:sp>
+        <p:nvSpPr>
+          <p:cNvPr id="13" name="Text 11"/>
+          <p:cNvSpPr/>
+          <p:nvPr/>
+        </p:nvSpPr>
+        <p:spPr>
+          <a:xfrm>
+            <a:off x="6400800" y="1874520"/>
+            <a:ext cx="5303520" cy="4206240"/>
+          </a:xfrm>
+          <a:prstGeom prst="rect">
+            <a:avLst/>
+          </a:prstGeom>
+          <a:noFill/>
+          <a:ln/>
+        </p:spPr>
+        <p:txBody>
+          <a:bodyPr wrap="square" lIns="0" tIns="0" rIns="0" bIns="0" rtlCol="0" anchor="ctr"/>
+          <a:lstStyle/>
+          <a:p>
+            <a:pPr marL="127000" indent="-127000">
+              <a:lnSpc>
+                <a:spcPts val="1200"/>
+              </a:lnSpc>
+              <a:spcAft>
+                <a:spcPts val="300"/>
+              </a:spcAft>
+              <a:buSzPct val="100000"/>
+              <a:buChar char="▸"/>
+            </a:pPr>
+            <a:r>
+              <a:rPr lang="en-US" b="1" dirty="0">
+                <a:solidFill>
+                  <a:srgbClr val="0A1628"/>
+                </a:solidFill>
+              </a:rPr>
+              <a:t>Eliminating the compute bottleneck</a:t>
+            </a:r>
+            <a:endParaRPr lang="en-US" dirty="0"/>
+          </a:p>
+          <a:p>
+            <a:pPr indent="0" marL="0">
+              <a:lnSpc>
+                <a:spcPts val="1200"/>
+              </a:lnSpc>
+              <a:spcAft>
+                <a:spcPts val="300"/>
+              </a:spcAft>
+              <a:buNone/>
+            </a:pPr>
+            <a:r>
+              <a:rPr lang="en-US" sz="900" dirty="0">
+                <a:solidFill>
+                  <a:srgbClr val="5A6B7A"/>
+                </a:solidFill>
+              </a:rPr>
+              <a:t>Every AI company today faces the same wall: GPU availability. The exhaust of computational capacity limits growth, forces queue management, and caps the number of users served. Owning sovereign infrastructure removes this ceiling entirely — we scale to demand, not to supply.</a:t>
+            </a:r>
+            <a:endParaRPr lang="en-US" sz="900" dirty="0"/>
+          </a:p>
+          <a:p>
+            <a:pPr indent="0" marL="0">
+              <a:lnSpc>
+                <a:spcPts val="1200"/>
+              </a:lnSpc>
+              <a:spcAft>
+                <a:spcPts val="300"/>
+              </a:spcAft>
+              <a:buNone/>
+            </a:pPr>
+            <a:r>
+              <a:rPr lang="en-US" sz="400" dirty="0">
+                <a:solidFill>
+                  <a:srgbClr val="000000"/>
+                </a:solidFill>
+              </a:rPr>
+              <a:t> </a:t>
+            </a:r>
+            <a:endParaRPr lang="en-US" sz="900" dirty="0"/>
+          </a:p>
+          <a:p>
+            <a:pPr marL="127000" indent="-127000">
+              <a:lnSpc>
+                <a:spcPts val="1200"/>
+              </a:lnSpc>
+              <a:spcAft>
+                <a:spcPts val="300"/>
+              </a:spcAft>
+              <a:buSzPct val="100000"/>
+              <a:buChar char="▸"/>
+            </a:pPr>
+            <a:r>
+              <a:rPr lang="en-US" sz="900" b="1" dirty="0">
+                <a:solidFill>
+                  <a:srgbClr val="0A1628"/>
+                </a:solidFill>
+              </a:rPr>
+              <a:t>LATAM presence with competitive latency</a:t>
+            </a:r>
+            <a:endParaRPr lang="en-US" sz="900" dirty="0"/>
+          </a:p>
+          <a:p>
+            <a:pPr indent="0" marL="0">
+              <a:lnSpc>
+                <a:spcPts val="1200"/>
+              </a:lnSpc>
+              <a:spcAft>
+                <a:spcPts val="300"/>
+              </a:spcAft>
+              <a:buNone/>
+            </a:pPr>
+            <a:r>
+              <a:rPr lang="en-US" sz="900" dirty="0">
+                <a:solidFill>
+                  <a:srgbClr val="5A6B7A"/>
+                </a:solidFill>
+              </a:rPr>
+              <a:t>The PB/CE data centers serve 400M+ Portuguese and Spanish speakers with latency that competes with US providers. No other AI infrastructure in Latin America offers this combination of sovereignty + performance + renewable energy.</a:t>
+            </a:r>
+            <a:endParaRPr lang="en-US" sz="900" dirty="0"/>
+          </a:p>
+          <a:p>
+            <a:pPr indent="0" marL="0">
+              <a:lnSpc>
+                <a:spcPts val="1200"/>
+              </a:lnSpc>
+              <a:spcAft>
+                <a:spcPts val="300"/>
+              </a:spcAft>
+              <a:buNone/>
+            </a:pPr>
+            <a:r>
+              <a:rPr lang="en-US" sz="400" dirty="0">
+                <a:solidFill>
+                  <a:srgbClr val="000000"/>
+                </a:solidFill>
+              </a:rPr>
+              <a:t> </a:t>
+            </a:r>
+            <a:endParaRPr lang="en-US" sz="900" dirty="0"/>
+          </a:p>
+          <a:p>
+            <a:pPr marL="127000" indent="-127000">
+              <a:lnSpc>
+                <a:spcPts val="1200"/>
+              </a:lnSpc>
+              <a:spcAft>
+                <a:spcPts val="300"/>
+              </a:spcAft>
+              <a:buSzPct val="100000"/>
+              <a:buChar char="▸"/>
+            </a:pPr>
+            <a:r>
+              <a:rPr lang="en-US" sz="900" b="1" dirty="0">
+                <a:solidFill>
+                  <a:srgbClr val="0A1628"/>
+                </a:solidFill>
+              </a:rPr>
+              <a:t>The asset appreciates</a:t>
+            </a:r>
+            <a:endParaRPr lang="en-US" sz="900" dirty="0"/>
+          </a:p>
+          <a:p>
+            <a:pPr indent="0" marL="0">
+              <a:lnSpc>
+                <a:spcPts val="1200"/>
+              </a:lnSpc>
+              <a:spcAft>
+                <a:spcPts val="300"/>
+              </a:spcAft>
+              <a:buNone/>
+            </a:pPr>
+            <a:r>
+              <a:rPr lang="en-US" sz="900" dirty="0">
+                <a:solidFill>
+                  <a:srgbClr val="5A6B7A"/>
+                </a:solidFill>
+              </a:rPr>
+              <a:t>Data centers, energy plants, and submarine cable access are appreciating infrastructure assets. The land is owned. The energy source is solar. The market for AI compute is growing 40%+ annually. This is not a cost — it is an investment that compounds.</a:t>
+            </a:r>
+            <a:endParaRPr lang="en-US" sz="900" dirty="0"/>
+          </a:p>
+          <a:p>
+            <a:pPr indent="0" marL="0">
+              <a:lnSpc>
+                <a:spcPts val="1200"/>
+              </a:lnSpc>
+              <a:spcAft>
+                <a:spcPts val="300"/>
+              </a:spcAft>
+              <a:buNone/>
+            </a:pPr>
+            <a:r>
+              <a:rPr lang="en-US" sz="400" dirty="0">
+                <a:solidFill>
+                  <a:srgbClr val="000000"/>
+                </a:solidFill>
+              </a:rPr>
+              <a:t> </a:t>
+            </a:r>
+            <a:endParaRPr lang="en-US" sz="900" dirty="0"/>
+          </a:p>
+          <a:p>
+            <a:pPr marL="127000" indent="-127000">
+              <a:lnSpc>
+                <a:spcPts val="1200"/>
+              </a:lnSpc>
+              <a:spcAft>
+                <a:spcPts val="300"/>
+              </a:spcAft>
+              <a:buSzPct val="100000"/>
+              <a:buChar char="▸"/>
+            </a:pPr>
+            <a:r>
+              <a:rPr lang="en-US" sz="900" b="1" dirty="0">
+                <a:solidFill>
+                  <a:srgbClr val="0A1628"/>
+                </a:solidFill>
+              </a:rPr>
+              <a:t>Energy cost = near zero</a:t>
+            </a:r>
+            <a:endParaRPr lang="en-US" sz="900" dirty="0"/>
+          </a:p>
+          <a:p>
+            <a:pPr indent="0" marL="0">
+              <a:lnSpc>
+                <a:spcPts val="1200"/>
+              </a:lnSpc>
+              <a:spcAft>
+                <a:spcPts val="300"/>
+              </a:spcAft>
+              <a:buNone/>
+            </a:pPr>
+            <a:r>
+              <a:rPr lang="en-US" sz="900" dirty="0">
+                <a:solidFill>
+                  <a:srgbClr val="5A6B7A"/>
+                </a:solidFill>
+              </a:rPr>
+              <a:t>Solar marginal cost approaches zero. Every GPU-hour served from PB costs less than any competitor running on grid power. This margin advantage compounds with scale.</a:t>
+            </a:r>
+            <a:endParaRPr lang="en-US" sz="900" dirty="0"/>
+          </a:p>
+        </p:txBody>
+      </p:sp>
+      <p:sp>
+        <p:nvSpPr>
+          <p:cNvPr id="14" name="Text 12"/>
+          <p:cNvSpPr/>
+          <p:nvPr/>
+        </p:nvSpPr>
+        <p:spPr>
+          <a:xfrm>
+            <a:off x="502920" y="6510528"/>
+            <a:ext cx="5486400" cy="256032"/>
+          </a:xfrm>
+          <a:prstGeom prst="rect">
+            <a:avLst/>
+          </a:prstGeom>
+          <a:noFill/>
+          <a:ln/>
+        </p:spPr>
+        <p:txBody>
+          <a:bodyPr wrap="square" lIns="0" tIns="0" rIns="0" bIns="0" rtlCol="0" anchor="ctr"/>
+          <a:lstStyle/>
+          <a:p>
+            <a:pPr indent="0" marL="0">
+              <a:buNone/>
+            </a:pPr>
+            <a:r>
+              <a:rPr lang="en-US" sz="800" dirty="0">
+                <a:solidFill>
+                  <a:srgbClr val="5A6B7A"/>
+                </a:solidFill>
+                <a:latin typeface="Helvetica Neue" pitchFamily="34" charset="0"/>
+                <a:ea typeface="Helvetica Neue" pitchFamily="34" charset="-122"/>
+                <a:cs typeface="Helvetica Neue" pitchFamily="34" charset="-120"/>
+              </a:rPr>
+              <a:t>BeansTech × Z.ai — Confidential</a:t>
+            </a:r>
+            <a:endParaRPr lang="en-US" sz="800" dirty="0"/>
+          </a:p>
+        </p:txBody>
+      </p:sp>
+      <p:sp>
+        <p:nvSpPr>
+          <p:cNvPr id="15" name="Text 13"/>
+          <p:cNvSpPr/>
+          <p:nvPr/>
+        </p:nvSpPr>
+        <p:spPr>
+          <a:xfrm>
+            <a:off x="11228832" y="6510528"/>
+            <a:ext cx="457200" cy="256032"/>
+          </a:xfrm>
+          <a:prstGeom prst="rect">
+            <a:avLst/>
+          </a:prstGeom>
+          <a:noFill/>
+          <a:ln/>
+        </p:spPr>
+        <p:txBody>
+          <a:bodyPr wrap="square" lIns="0" tIns="0" rIns="0" bIns="0" rtlCol="0" anchor="ctr"/>
+          <a:lstStyle/>
+          <a:p>
+            <a:pPr algn="r" indent="0" marL="0">
+              <a:buNone/>
+            </a:pPr>
+            <a:r>
+              <a:rPr lang="en-US" sz="800" dirty="0">
+                <a:solidFill>
+                  <a:srgbClr val="5A6B7A"/>
+                </a:solidFill>
+                <a:latin typeface="Helvetica Neue" pitchFamily="34" charset="0"/>
+                <a:ea typeface="Helvetica Neue" pitchFamily="34" charset="-122"/>
+                <a:cs typeface="Helvetica Neue" pitchFamily="34" charset="-120"/>
+              </a:rPr>
+              <a:t>10</a:t>
+            </a:r>
+            <a:endParaRPr lang="en-US" sz="800" dirty="0"/>
+          </a:p>
+        </p:txBody>
+      </p:sp>
+    </p:spTree>
+  </p:cSld>
+  <p:clrMapOvr>
+    <a:masterClrMapping/>
+  </p:clrMapOvr>
+</p:sld>
+</file>
+
+<file path=ppt/slides/slide11.xml><?xml version="1.0" encoding="utf-8"?>
+<p:sld xmlns:a="http://schemas.openxmlformats.org/drawingml/2006/main" xmlns:r="http://schemas.openxmlformats.org/officeDocument/2006/relationships" xmlns:p="http://schemas.openxmlformats.org/presentationml/2006/main">
+  <p:cSld name="Slide 11">
+    <p:bg>
+      <p:bgPr>
+        <a:solidFill>
           <a:srgbClr val="0A1628"/>
         </a:solidFill>
       </p:bgPr>
@@ -3674,7 +4619,7 @@
                 <a:ea typeface="Helvetica Neue" pitchFamily="34" charset="-122"/>
                 <a:cs typeface="Helvetica Neue" pitchFamily="34" charset="-120"/>
               </a:rPr>
-              <a:t>10</a:t>
+              <a:t>11</a:t>
             </a:r>
             <a:endParaRPr lang="en-US" sz="800" dirty="0"/>
           </a:p>
@@ -3688,9 +4633,9 @@
 </p:sld>
 </file>
 
-<file path=ppt/slides/slide11.xml><?xml version="1.0" encoding="utf-8"?>
+<file path=ppt/slides/slide12.xml><?xml version="1.0" encoding="utf-8"?>
 <p:sld xmlns:a="http://schemas.openxmlformats.org/drawingml/2006/main" xmlns:r="http://schemas.openxmlformats.org/officeDocument/2006/relationships" xmlns:p="http://schemas.openxmlformats.org/presentationml/2006/main">
-  <p:cSld name="Slide 11">
+  <p:cSld name="Slide 12">
     <p:bg>
       <p:bgPr>
         <a:solidFill>
@@ -4546,7 +5491,7 @@
                 <a:ea typeface="Helvetica Neue" pitchFamily="34" charset="-122"/>
                 <a:cs typeface="Helvetica Neue" pitchFamily="34" charset="-120"/>
               </a:rPr>
-              <a:t>11</a:t>
+              <a:t>12</a:t>
             </a:r>
             <a:endParaRPr lang="en-US" sz="800" dirty="0"/>
           </a:p>
@@ -4560,9 +5505,9 @@
 </p:sld>
 </file>
 
-<file path=ppt/slides/slide12.xml><?xml version="1.0" encoding="utf-8"?>
+<file path=ppt/slides/slide13.xml><?xml version="1.0" encoding="utf-8"?>
 <p:sld xmlns:a="http://schemas.openxmlformats.org/drawingml/2006/main" xmlns:r="http://schemas.openxmlformats.org/officeDocument/2006/relationships" xmlns:p="http://schemas.openxmlformats.org/presentationml/2006/main">
-  <p:cSld name="Slide 12">
+  <p:cSld name="Slide 13">
     <p:bg>
       <p:bgPr>
         <a:solidFill>
@@ -5339,7 +6284,7 @@
                 <a:ea typeface="Georgia" pitchFamily="34" charset="-122"/>
                 <a:cs typeface="Georgia" pitchFamily="34" charset="-120"/>
               </a:rPr>
-              <a:t>US$ 643M revenue (5yr) · US$ 2.2B enterprise value at exit · 7.4× return</a:t>
+              <a:t>US$ 943M revenue (5yr) · US$ 3.2B enterprise value at exit · 10.7× return</a:t>
             </a:r>
             <a:endParaRPr lang="en-US" sz="3600" dirty="0"/>
           </a:p>
@@ -5479,7 +6424,7 @@
                 <a:ea typeface="Helvetica Neue" pitchFamily="34" charset="-122"/>
                 <a:cs typeface="Helvetica Neue" pitchFamily="34" charset="-120"/>
               </a:rPr>
-              <a:t>12</a:t>
+              <a:t>13</a:t>
             </a:r>
             <a:endParaRPr lang="en-US" sz="800" dirty="0"/>
           </a:p>
@@ -12268,7 +13213,7 @@
                 <a:ea typeface="Helvetica Neue" pitchFamily="34" charset="-122"/>
                 <a:cs typeface="Helvetica Neue" pitchFamily="34" charset="-120"/>
               </a:rPr>
-              <a:t>The Data Center Advantage</a:t>
+              <a:t>The Data Center Advantage: Sovereignty, Latency, and Compute at Scale</a:t>
             </a:r>
             <a:endParaRPr lang="en-US" sz="3000" dirty="0"/>
           </a:p>
@@ -12307,7 +13252,7 @@
                 <a:ea typeface="Helvetica Neue" pitchFamily="34" charset="-122"/>
                 <a:cs typeface="Helvetica Neue" pitchFamily="34" charset="-120"/>
               </a:rPr>
-              <a:t>Santa Terezinha/PB (solar + satellite) + ZPE Caucaia/CE (same ZPE as TikTok)</a:t>
+              <a:t>Santa Terezinha/PB (solar + satellite) + ZPE Caucaia/CE (same ZPE as TikTok) — eliminating the compute bottleneck that constrains every AI company today</a:t>
             </a:r>
             <a:endParaRPr lang="en-US" sz="1300" dirty="0"/>
           </a:p>
@@ -15319,7 +16264,7 @@
                 <a:ea typeface="Helvetica Neue" pitchFamily="34" charset="-122"/>
                 <a:cs typeface="Helvetica Neue" pitchFamily="34" charset="-120"/>
               </a:rPr>
-              <a:t>Global Revenue Projection</a:t>
+              <a:t>Global Revenue Projection — The Return Is Far Greater Than It Appears</a:t>
             </a:r>
             <a:endParaRPr lang="en-US" sz="3000" dirty="0"/>
           </a:p>
@@ -15358,7 +16303,7 @@
                 <a:ea typeface="Helvetica Neue" pitchFamily="34" charset="-122"/>
                 <a:cs typeface="Helvetica Neue" pitchFamily="34" charset="-120"/>
               </a:rPr>
-              <a:t>US$ 300M partnership → US$ 643M cumulative revenue (5 years) → US$ 2.2B enterprise value at exit</a:t>
+              <a:t>US$ 300M partnership → US$ 943M cumulative revenue (5 years) → US$ 3.2B enterprise value at exit</a:t>
             </a:r>
             <a:endParaRPr lang="en-US" sz="1300" dirty="0"/>
           </a:p>
@@ -15585,7 +16530,7 @@
                           <a:ea typeface="Helvetica Neue" pitchFamily="34" charset="-122"/>
                           <a:cs typeface="Helvetica Neue" pitchFamily="34" charset="-120"/>
                         </a:rPr>
-                        <a:t>Brazil (all verticals)</a:t>
+                        <a:t>Brazil (SaaS + API)</a:t>
                       </a:r>
                       <a:endParaRPr lang="en-US" sz="950" dirty="0">
                         <a:latin typeface="Helvetica Neue" charset="0"/>
@@ -15791,7 +16736,7 @@
                           <a:ea typeface="Helvetica Neue" pitchFamily="34" charset="-122"/>
                           <a:cs typeface="Helvetica Neue" pitchFamily="34" charset="-120"/>
                         </a:rPr>
-                        <a:t>60</a:t>
+                        <a:t>80</a:t>
                       </a:r>
                       <a:endParaRPr lang="en-US" sz="950" dirty="0">
                         <a:latin typeface="Helvetica Neue" charset="0"/>
@@ -15929,7 +16874,7 @@
                           <a:ea typeface="Helvetica Neue" pitchFamily="34" charset="-122"/>
                           <a:cs typeface="Helvetica Neue" pitchFamily="34" charset="-120"/>
                         </a:rPr>
-                        <a:t>40</a:t>
+                        <a:t>55</a:t>
                       </a:r>
                       <a:endParaRPr lang="en-US" sz="950" dirty="0">
                         <a:latin typeface="Helvetica Neue" charset="0"/>
@@ -16067,7 +17012,7 @@
                           <a:ea typeface="Helvetica Neue" pitchFamily="34" charset="-122"/>
                           <a:cs typeface="Helvetica Neue" pitchFamily="34" charset="-120"/>
                         </a:rPr>
-                        <a:t>25</a:t>
+                        <a:t>35</a:t>
                       </a:r>
                       <a:endParaRPr lang="en-US" sz="950" dirty="0">
                         <a:latin typeface="Helvetica Neue" charset="0"/>
@@ -16267,6 +17212,420 @@
                         <a:buNone/>
                       </a:pPr>
                       <a:r>
+                        <a:rPr lang="en-US" sz="950" dirty="0">
+                          <a:solidFill>
+                            <a:srgbClr val="1A2332"/>
+                          </a:solidFill>
+                          <a:latin typeface="Helvetica Neue" pitchFamily="34" charset="0"/>
+                          <a:ea typeface="Helvetica Neue" pitchFamily="34" charset="-122"/>
+                          <a:cs typeface="Helvetica Neue" pitchFamily="34" charset="-120"/>
+                        </a:rPr>
+                        <a:t>Compute-as-a-Service (GPU cloud)</a:t>
+                      </a:r>
+                      <a:endParaRPr lang="en-US" sz="950" dirty="0">
+                        <a:latin typeface="Helvetica Neue" charset="0"/>
+                        <a:ea typeface="Helvetica Neue" charset="0"/>
+                        <a:cs typeface="Helvetica Neue" charset="0"/>
+                      </a:endParaRPr>
+                    </a:p>
+                  </a:txBody>
+                  <a:tcPr marL="91440" marR="91440" marT="45720" marB="45720" anchor="ctr">
+                    <a:lnL w="6350" cap="flat" cmpd="sng" algn="ctr">
+                      <a:solidFill>
+                        <a:srgbClr val="C8D2DA"/>
+                      </a:solidFill>
+                      <a:prstDash val="solid"/>
+                      <a:round/>
+                      <a:headEnd type="none" w="med" len="med"/>
+                      <a:tailEnd type="none" w="med" len="med"/>
+                    </a:lnL>
+                    <a:lnR w="6350" cap="flat" cmpd="sng" algn="ctr">
+                      <a:solidFill>
+                        <a:srgbClr val="C8D2DA"/>
+                      </a:solidFill>
+                      <a:prstDash val="solid"/>
+                      <a:round/>
+                      <a:headEnd type="none" w="med" len="med"/>
+                      <a:tailEnd type="none" w="med" len="med"/>
+                    </a:lnR>
+                    <a:lnT w="6350" cap="flat" cmpd="sng" algn="ctr">
+                      <a:solidFill>
+                        <a:srgbClr val="C8D2DA"/>
+                      </a:solidFill>
+                      <a:prstDash val="solid"/>
+                      <a:round/>
+                      <a:headEnd type="none" w="med" len="med"/>
+                      <a:tailEnd type="none" w="med" len="med"/>
+                    </a:lnT>
+                    <a:lnB w="6350" cap="flat" cmpd="sng" algn="ctr">
+                      <a:solidFill>
+                        <a:srgbClr val="C8D2DA"/>
+                      </a:solidFill>
+                      <a:prstDash val="solid"/>
+                      <a:round/>
+                      <a:headEnd type="none" w="med" len="med"/>
+                      <a:tailEnd type="none" w="med" len="med"/>
+                    </a:lnB>
+                    <a:solidFill>
+                      <a:srgbClr val="F0F4F7"/>
+                    </a:solidFill>
+                  </a:tcPr>
+                </a:tc>
+                <a:tc>
+                  <a:txBody>
+                    <a:bodyPr/>
+                    <a:lstStyle/>
+                    <a:p>
+                      <a:pPr algn="r" indent="0" marL="0">
+                        <a:buNone/>
+                      </a:pPr>
+                      <a:r>
+                        <a:rPr lang="en-US" sz="950" dirty="0">
+                          <a:solidFill>
+                            <a:srgbClr val="1A2332"/>
+                          </a:solidFill>
+                          <a:latin typeface="Helvetica Neue" pitchFamily="34" charset="0"/>
+                          <a:ea typeface="Helvetica Neue" pitchFamily="34" charset="-122"/>
+                          <a:cs typeface="Helvetica Neue" pitchFamily="34" charset="-120"/>
+                        </a:rPr>
+                        <a:t>45</a:t>
+                      </a:r>
+                      <a:endParaRPr lang="en-US" sz="950" dirty="0">
+                        <a:latin typeface="Helvetica Neue" charset="0"/>
+                        <a:ea typeface="Helvetica Neue" charset="0"/>
+                        <a:cs typeface="Helvetica Neue" charset="0"/>
+                      </a:endParaRPr>
+                    </a:p>
+                  </a:txBody>
+                  <a:tcPr marL="91440" marR="91440" marT="45720" marB="45720" anchor="ctr">
+                    <a:lnL w="6350" cap="flat" cmpd="sng" algn="ctr">
+                      <a:solidFill>
+                        <a:srgbClr val="C8D2DA"/>
+                      </a:solidFill>
+                      <a:prstDash val="solid"/>
+                      <a:round/>
+                      <a:headEnd type="none" w="med" len="med"/>
+                      <a:tailEnd type="none" w="med" len="med"/>
+                    </a:lnL>
+                    <a:lnR w="6350" cap="flat" cmpd="sng" algn="ctr">
+                      <a:solidFill>
+                        <a:srgbClr val="C8D2DA"/>
+                      </a:solidFill>
+                      <a:prstDash val="solid"/>
+                      <a:round/>
+                      <a:headEnd type="none" w="med" len="med"/>
+                      <a:tailEnd type="none" w="med" len="med"/>
+                    </a:lnR>
+                    <a:lnT w="6350" cap="flat" cmpd="sng" algn="ctr">
+                      <a:solidFill>
+                        <a:srgbClr val="C8D2DA"/>
+                      </a:solidFill>
+                      <a:prstDash val="solid"/>
+                      <a:round/>
+                      <a:headEnd type="none" w="med" len="med"/>
+                      <a:tailEnd type="none" w="med" len="med"/>
+                    </a:lnT>
+                    <a:lnB w="6350" cap="flat" cmpd="sng" algn="ctr">
+                      <a:solidFill>
+                        <a:srgbClr val="C8D2DA"/>
+                      </a:solidFill>
+                      <a:prstDash val="solid"/>
+                      <a:round/>
+                      <a:headEnd type="none" w="med" len="med"/>
+                      <a:tailEnd type="none" w="med" len="med"/>
+                    </a:lnB>
+                    <a:solidFill>
+                      <a:srgbClr val="F0F4F7"/>
+                    </a:solidFill>
+                  </a:tcPr>
+                </a:tc>
+              </a:tr>
+              <a:tr h="347472">
+                <a:tc>
+                  <a:txBody>
+                    <a:bodyPr/>
+                    <a:lstStyle/>
+                    <a:p>
+                      <a:pPr algn="l" indent="0" marL="0">
+                        <a:buNone/>
+                      </a:pPr>
+                      <a:r>
+                        <a:rPr lang="en-US" sz="950" dirty="0">
+                          <a:solidFill>
+                            <a:srgbClr val="1A2332"/>
+                          </a:solidFill>
+                          <a:latin typeface="Helvetica Neue" pitchFamily="34" charset="0"/>
+                          <a:ea typeface="Helvetica Neue" pitchFamily="34" charset="-122"/>
+                          <a:cs typeface="Helvetica Neue" pitchFamily="34" charset="-120"/>
+                        </a:rPr>
+                        <a:t>Sovereign Cloud (z.cloud API)</a:t>
+                      </a:r>
+                      <a:endParaRPr lang="en-US" sz="950" dirty="0">
+                        <a:latin typeface="Helvetica Neue" charset="0"/>
+                        <a:ea typeface="Helvetica Neue" charset="0"/>
+                        <a:cs typeface="Helvetica Neue" charset="0"/>
+                      </a:endParaRPr>
+                    </a:p>
+                  </a:txBody>
+                  <a:tcPr marL="91440" marR="91440" marT="45720" marB="45720" anchor="ctr">
+                    <a:lnL w="6350" cap="flat" cmpd="sng" algn="ctr">
+                      <a:solidFill>
+                        <a:srgbClr val="C8D2DA"/>
+                      </a:solidFill>
+                      <a:prstDash val="solid"/>
+                      <a:round/>
+                      <a:headEnd type="none" w="med" len="med"/>
+                      <a:tailEnd type="none" w="med" len="med"/>
+                    </a:lnL>
+                    <a:lnR w="6350" cap="flat" cmpd="sng" algn="ctr">
+                      <a:solidFill>
+                        <a:srgbClr val="C8D2DA"/>
+                      </a:solidFill>
+                      <a:prstDash val="solid"/>
+                      <a:round/>
+                      <a:headEnd type="none" w="med" len="med"/>
+                      <a:tailEnd type="none" w="med" len="med"/>
+                    </a:lnR>
+                    <a:lnT w="6350" cap="flat" cmpd="sng" algn="ctr">
+                      <a:solidFill>
+                        <a:srgbClr val="C8D2DA"/>
+                      </a:solidFill>
+                      <a:prstDash val="solid"/>
+                      <a:round/>
+                      <a:headEnd type="none" w="med" len="med"/>
+                      <a:tailEnd type="none" w="med" len="med"/>
+                    </a:lnT>
+                    <a:lnB w="6350" cap="flat" cmpd="sng" algn="ctr">
+                      <a:solidFill>
+                        <a:srgbClr val="C8D2DA"/>
+                      </a:solidFill>
+                      <a:prstDash val="solid"/>
+                      <a:round/>
+                      <a:headEnd type="none" w="med" len="med"/>
+                      <a:tailEnd type="none" w="med" len="med"/>
+                    </a:lnB>
+                    <a:solidFill>
+                      <a:srgbClr val="FFFFFF"/>
+                    </a:solidFill>
+                  </a:tcPr>
+                </a:tc>
+                <a:tc>
+                  <a:txBody>
+                    <a:bodyPr/>
+                    <a:lstStyle/>
+                    <a:p>
+                      <a:pPr algn="r" indent="0" marL="0">
+                        <a:buNone/>
+                      </a:pPr>
+                      <a:r>
+                        <a:rPr lang="en-US" sz="950" dirty="0">
+                          <a:solidFill>
+                            <a:srgbClr val="1A2332"/>
+                          </a:solidFill>
+                          <a:latin typeface="Helvetica Neue" pitchFamily="34" charset="0"/>
+                          <a:ea typeface="Helvetica Neue" pitchFamily="34" charset="-122"/>
+                          <a:cs typeface="Helvetica Neue" pitchFamily="34" charset="-120"/>
+                        </a:rPr>
+                        <a:t>60</a:t>
+                      </a:r>
+                      <a:endParaRPr lang="en-US" sz="950" dirty="0">
+                        <a:latin typeface="Helvetica Neue" charset="0"/>
+                        <a:ea typeface="Helvetica Neue" charset="0"/>
+                        <a:cs typeface="Helvetica Neue" charset="0"/>
+                      </a:endParaRPr>
+                    </a:p>
+                  </a:txBody>
+                  <a:tcPr marL="91440" marR="91440" marT="45720" marB="45720" anchor="ctr">
+                    <a:lnL w="6350" cap="flat" cmpd="sng" algn="ctr">
+                      <a:solidFill>
+                        <a:srgbClr val="C8D2DA"/>
+                      </a:solidFill>
+                      <a:prstDash val="solid"/>
+                      <a:round/>
+                      <a:headEnd type="none" w="med" len="med"/>
+                      <a:tailEnd type="none" w="med" len="med"/>
+                    </a:lnL>
+                    <a:lnR w="6350" cap="flat" cmpd="sng" algn="ctr">
+                      <a:solidFill>
+                        <a:srgbClr val="C8D2DA"/>
+                      </a:solidFill>
+                      <a:prstDash val="solid"/>
+                      <a:round/>
+                      <a:headEnd type="none" w="med" len="med"/>
+                      <a:tailEnd type="none" w="med" len="med"/>
+                    </a:lnR>
+                    <a:lnT w="6350" cap="flat" cmpd="sng" algn="ctr">
+                      <a:solidFill>
+                        <a:srgbClr val="C8D2DA"/>
+                      </a:solidFill>
+                      <a:prstDash val="solid"/>
+                      <a:round/>
+                      <a:headEnd type="none" w="med" len="med"/>
+                      <a:tailEnd type="none" w="med" len="med"/>
+                    </a:lnT>
+                    <a:lnB w="6350" cap="flat" cmpd="sng" algn="ctr">
+                      <a:solidFill>
+                        <a:srgbClr val="C8D2DA"/>
+                      </a:solidFill>
+                      <a:prstDash val="solid"/>
+                      <a:round/>
+                      <a:headEnd type="none" w="med" len="med"/>
+                      <a:tailEnd type="none" w="med" len="med"/>
+                    </a:lnB>
+                    <a:solidFill>
+                      <a:srgbClr val="FFFFFF"/>
+                    </a:solidFill>
+                  </a:tcPr>
+                </a:tc>
+              </a:tr>
+              <a:tr h="347472">
+                <a:tc>
+                  <a:txBody>
+                    <a:bodyPr/>
+                    <a:lstStyle/>
+                    <a:p>
+                      <a:pPr algn="l" indent="0" marL="0">
+                        <a:buNone/>
+                      </a:pPr>
+                      <a:r>
+                        <a:rPr lang="en-US" sz="950" dirty="0">
+                          <a:solidFill>
+                            <a:srgbClr val="1A2332"/>
+                          </a:solidFill>
+                          <a:latin typeface="Helvetica Neue" pitchFamily="34" charset="0"/>
+                          <a:ea typeface="Helvetica Neue" pitchFamily="34" charset="-122"/>
+                          <a:cs typeface="Helvetica Neue" pitchFamily="34" charset="-120"/>
+                        </a:rPr>
+                        <a:t>Colocation (ZPE CE)</a:t>
+                      </a:r>
+                      <a:endParaRPr lang="en-US" sz="950" dirty="0">
+                        <a:latin typeface="Helvetica Neue" charset="0"/>
+                        <a:ea typeface="Helvetica Neue" charset="0"/>
+                        <a:cs typeface="Helvetica Neue" charset="0"/>
+                      </a:endParaRPr>
+                    </a:p>
+                  </a:txBody>
+                  <a:tcPr marL="91440" marR="91440" marT="45720" marB="45720" anchor="ctr">
+                    <a:lnL w="6350" cap="flat" cmpd="sng" algn="ctr">
+                      <a:solidFill>
+                        <a:srgbClr val="C8D2DA"/>
+                      </a:solidFill>
+                      <a:prstDash val="solid"/>
+                      <a:round/>
+                      <a:headEnd type="none" w="med" len="med"/>
+                      <a:tailEnd type="none" w="med" len="med"/>
+                    </a:lnL>
+                    <a:lnR w="6350" cap="flat" cmpd="sng" algn="ctr">
+                      <a:solidFill>
+                        <a:srgbClr val="C8D2DA"/>
+                      </a:solidFill>
+                      <a:prstDash val="solid"/>
+                      <a:round/>
+                      <a:headEnd type="none" w="med" len="med"/>
+                      <a:tailEnd type="none" w="med" len="med"/>
+                    </a:lnR>
+                    <a:lnT w="6350" cap="flat" cmpd="sng" algn="ctr">
+                      <a:solidFill>
+                        <a:srgbClr val="C8D2DA"/>
+                      </a:solidFill>
+                      <a:prstDash val="solid"/>
+                      <a:round/>
+                      <a:headEnd type="none" w="med" len="med"/>
+                      <a:tailEnd type="none" w="med" len="med"/>
+                    </a:lnT>
+                    <a:lnB w="6350" cap="flat" cmpd="sng" algn="ctr">
+                      <a:solidFill>
+                        <a:srgbClr val="C8D2DA"/>
+                      </a:solidFill>
+                      <a:prstDash val="solid"/>
+                      <a:round/>
+                      <a:headEnd type="none" w="med" len="med"/>
+                      <a:tailEnd type="none" w="med" len="med"/>
+                    </a:lnB>
+                    <a:solidFill>
+                      <a:srgbClr val="F0F4F7"/>
+                    </a:solidFill>
+                  </a:tcPr>
+                </a:tc>
+                <a:tc>
+                  <a:txBody>
+                    <a:bodyPr/>
+                    <a:lstStyle/>
+                    <a:p>
+                      <a:pPr algn="r" indent="0" marL="0">
+                        <a:buNone/>
+                      </a:pPr>
+                      <a:r>
+                        <a:rPr lang="en-US" sz="950" dirty="0">
+                          <a:solidFill>
+                            <a:srgbClr val="1A2332"/>
+                          </a:solidFill>
+                          <a:latin typeface="Helvetica Neue" pitchFamily="34" charset="0"/>
+                          <a:ea typeface="Helvetica Neue" pitchFamily="34" charset="-122"/>
+                          <a:cs typeface="Helvetica Neue" pitchFamily="34" charset="-120"/>
+                        </a:rPr>
+                        <a:t>25</a:t>
+                      </a:r>
+                      <a:endParaRPr lang="en-US" sz="950" dirty="0">
+                        <a:latin typeface="Helvetica Neue" charset="0"/>
+                        <a:ea typeface="Helvetica Neue" charset="0"/>
+                        <a:cs typeface="Helvetica Neue" charset="0"/>
+                      </a:endParaRPr>
+                    </a:p>
+                  </a:txBody>
+                  <a:tcPr marL="91440" marR="91440" marT="45720" marB="45720" anchor="ctr">
+                    <a:lnL w="6350" cap="flat" cmpd="sng" algn="ctr">
+                      <a:solidFill>
+                        <a:srgbClr val="C8D2DA"/>
+                      </a:solidFill>
+                      <a:prstDash val="solid"/>
+                      <a:round/>
+                      <a:headEnd type="none" w="med" len="med"/>
+                      <a:tailEnd type="none" w="med" len="med"/>
+                    </a:lnL>
+                    <a:lnR w="6350" cap="flat" cmpd="sng" algn="ctr">
+                      <a:solidFill>
+                        <a:srgbClr val="C8D2DA"/>
+                      </a:solidFill>
+                      <a:prstDash val="solid"/>
+                      <a:round/>
+                      <a:headEnd type="none" w="med" len="med"/>
+                      <a:tailEnd type="none" w="med" len="med"/>
+                    </a:lnR>
+                    <a:lnT w="6350" cap="flat" cmpd="sng" algn="ctr">
+                      <a:solidFill>
+                        <a:srgbClr val="C8D2DA"/>
+                      </a:solidFill>
+                      <a:prstDash val="solid"/>
+                      <a:round/>
+                      <a:headEnd type="none" w="med" len="med"/>
+                      <a:tailEnd type="none" w="med" len="med"/>
+                    </a:lnT>
+                    <a:lnB w="6350" cap="flat" cmpd="sng" algn="ctr">
+                      <a:solidFill>
+                        <a:srgbClr val="C8D2DA"/>
+                      </a:solidFill>
+                      <a:prstDash val="solid"/>
+                      <a:round/>
+                      <a:headEnd type="none" w="med" len="med"/>
+                      <a:tailEnd type="none" w="med" len="med"/>
+                    </a:lnB>
+                    <a:solidFill>
+                      <a:srgbClr val="F0F4F7"/>
+                    </a:solidFill>
+                  </a:tcPr>
+                </a:tc>
+              </a:tr>
+              <a:tr h="347472">
+                <a:tc>
+                  <a:txBody>
+                    <a:bodyPr/>
+                    <a:lstStyle/>
+                    <a:p>
+                      <a:pPr algn="l" indent="0" marL="0">
+                        <a:buNone/>
+                      </a:pPr>
+                      <a:r>
                         <a:rPr lang="en-US" sz="950" b="1" dirty="0">
                           <a:solidFill>
                             <a:srgbClr val="C9A227"/>
@@ -16343,7 +17702,7 @@
                           <a:ea typeface="Helvetica Neue" pitchFamily="34" charset="-122"/>
                           <a:cs typeface="Helvetica Neue" pitchFamily="34" charset="-120"/>
                         </a:rPr>
-                        <a:t>279</a:t>
+                        <a:t>454</a:t>
                       </a:r>
                       <a:endParaRPr lang="en-US" sz="950" dirty="0">
                         <a:latin typeface="Helvetica Neue" charset="0"/>
@@ -16457,7 +17816,7 @@
                   <a:srgbClr val="E8C847"/>
                 </a:solidFill>
               </a:rPr>
-              <a:t>US$ 300M Investment → US$ 643M Revenue (5 years) → US$ 2.2B Enterprise Value at Exit</a:t>
+              <a:t>US$ 300M Investment → US$ 943M Revenue (5 years) → US$ 3.2B Enterprise Value at Exit</a:t>
             </a:r>
             <a:endParaRPr lang="en-US" sz="1400" dirty="0"/>
           </a:p>
@@ -16474,7 +17833,7 @@
                   <a:srgbClr val="B0C4D4"/>
                 </a:solidFill>
               </a:rPr>
-              <a:t>Direct ROI: 2.1×  ·  Enterprise Value Multiple: 7.4×  ·  Year 5 Run-Rate: US$ 279M/year</a:t>
+              <a:t>Direct ROI: 3.1×  ·  Enterprise Value Multiple: 10.7×  ·  Year 5 Run-Rate: US$ 420M/year</a:t>
             </a:r>
             <a:endParaRPr lang="en-US" sz="1400" dirty="0"/>
           </a:p>

</xml_diff>

<commit_message>
Deck: 16 GPUs removido; 2 data centers (1 carbon-free) no stats; balance statement no slide The Ask
</commit_message>
<xml_diff>
--- a/apresentacoes/ZCloud-Zai-Parceria-EN.pptx
+++ b/apresentacoes/ZCloud-Zai-Parceria-EN.pptx
@@ -4729,7 +4729,7 @@
                 <a:ea typeface="Helvetica Neue" pitchFamily="34" charset="-122"/>
                 <a:cs typeface="Helvetica Neue" pitchFamily="34" charset="-120"/>
               </a:rPr>
-              <a:t>A partnership of equals, each bringing what the other cannot build alone</a:t>
+              <a:t>A balanced partnership of equals — each side contributing what the other cannot build alone</a:t>
             </a:r>
             <a:endParaRPr lang="en-US" sz="1300" dirty="0"/>
           </a:p>
@@ -5169,7 +5169,7 @@
                   <a:srgbClr val="5A6B7A"/>
                 </a:solidFill>
               </a:rPr>
-              <a:t>16 GPUs, 6 models, 31 health probes, 8 portals — all live and auditable</a:t>
+              <a:t>6 models, 31 health probes, 8 portals live, 2 data center sites secured (PB solar + CE ZPE)</a:t>
             </a:r>
             <a:endParaRPr lang="en-US" sz="900" dirty="0"/>
           </a:p>
@@ -5421,7 +5421,85 @@
       </p:sp>
       <p:sp>
         <p:nvSpPr>
-          <p:cNvPr id="11" name="Text 9"/>
+          <p:cNvPr id="11" name="Shape 9"/>
+          <p:cNvSpPr/>
+          <p:nvPr/>
+        </p:nvSpPr>
+        <p:spPr>
+          <a:xfrm>
+            <a:off x="502920" y="5486400"/>
+            <a:ext cx="11183112" cy="731520"/>
+          </a:xfrm>
+          <a:prstGeom prst="rect">
+            <a:avLst/>
+          </a:prstGeom>
+          <a:solidFill>
+            <a:srgbClr val="F0F4F7"/>
+          </a:solidFill>
+          <a:ln w="12700">
+            <a:solidFill>
+              <a:srgbClr val="C9A227"/>
+            </a:solidFill>
+            <a:prstDash val="solid"/>
+          </a:ln>
+        </p:spPr>
+      </p:sp>
+      <p:sp>
+        <p:nvSpPr>
+          <p:cNvPr id="12" name="Text 10"/>
+          <p:cNvSpPr/>
+          <p:nvPr/>
+        </p:nvSpPr>
+        <p:spPr>
+          <a:xfrm>
+            <a:off x="685800" y="5577840"/>
+            <a:ext cx="10817352" cy="548640"/>
+          </a:xfrm>
+          <a:prstGeom prst="rect">
+            <a:avLst/>
+          </a:prstGeom>
+          <a:noFill/>
+          <a:ln/>
+        </p:spPr>
+        <p:txBody>
+          <a:bodyPr wrap="square" lIns="0" tIns="0" rIns="0" bIns="0" rtlCol="0" anchor="ctr"/>
+          <a:lstStyle/>
+          <a:p>
+            <a:pPr indent="0" marL="0">
+              <a:lnSpc>
+                <a:spcPts val="1200"/>
+              </a:lnSpc>
+              <a:buNone/>
+            </a:pPr>
+            <a:r>
+              <a:rPr lang="en-US" sz="1000" b="1" dirty="0">
+                <a:solidFill>
+                  <a:srgbClr val="0A1628"/>
+                </a:solidFill>
+              </a:rPr>
+              <a:t>On Balance: </a:t>
+            </a:r>
+            <a:pPr indent="0" marL="0">
+              <a:lnSpc>
+                <a:spcPts val="1200"/>
+              </a:lnSpc>
+              <a:buNone/>
+            </a:pPr>
+            <a:r>
+              <a:rPr lang="en-US" sz="950" dirty="0">
+                <a:solidFill>
+                  <a:srgbClr val="5A6B7A"/>
+                </a:solidFill>
+              </a:rPr>
+              <a:t>We recognize that another company could invest more capital. What cannot be replicated at any price: regulatory expertise, production infrastructure, sovereign land, premium domains, and a clinical benchmark that independently validated GLM. The partnership is balanced because each side contributes what money alone cannot buy.</a:t>
+            </a:r>
+            <a:endParaRPr lang="en-US" sz="1000" dirty="0"/>
+          </a:p>
+        </p:txBody>
+      </p:sp>
+      <p:sp>
+        <p:nvSpPr>
+          <p:cNvPr id="13" name="Text 11"/>
           <p:cNvSpPr/>
           <p:nvPr/>
         </p:nvSpPr>
@@ -5460,7 +5538,7 @@
       </p:sp>
       <p:sp>
         <p:nvSpPr>
-          <p:cNvPr id="12" name="Text 10"/>
+          <p:cNvPr id="14" name="Text 12"/>
           <p:cNvSpPr/>
           <p:nvPr/>
         </p:nvSpPr>
@@ -6930,7 +7008,7 @@
                 <a:ea typeface="Helvetica Neue" pitchFamily="34" charset="-122"/>
                 <a:cs typeface="Helvetica Neue" pitchFamily="34" charset="-120"/>
               </a:rPr>
-              <a:t>16</a:t>
+              <a:t>2</a:t>
             </a:r>
             <a:endParaRPr lang="en-US" sz="2200" dirty="0"/>
           </a:p>
@@ -6969,7 +7047,7 @@
                 <a:ea typeface="Helvetica Neue" pitchFamily="34" charset="-122"/>
                 <a:cs typeface="Helvetica Neue" pitchFamily="34" charset="-120"/>
               </a:rPr>
-              <a:t>GPUs in Production</a:t>
+              <a:t>Data Centers (1 Carbon-Free)</a:t>
             </a:r>
             <a:endParaRPr lang="en-US" sz="850" dirty="0"/>
           </a:p>
@@ -7153,7 +7231,7 @@
                   <a:srgbClr val="B0C4D4"/>
                 </a:solidFill>
               </a:rPr>
-              <a:t>What typically takes years to build (infrastructure, regulatory expertise, distribution, domains) is already operational. BeansTech runs 16 GPUs, 6 frontier models, 8 medical portals, a complete compliance stack — and a clinical benchmark that validated GLM-5.3 as the top performer.</a:t>
+              <a:t>What typically takes years to build (infrastructure, regulatory expertise, distribution, domains) is already operational. BeansTech runs 6 frontier models, 8 medical portals, a complete compliance stack, and has secured land for two sovereign data centers — and a clinical benchmark that validated GLM-5.3 as the top performer.</a:t>
             </a:r>
             <a:endParaRPr lang="en-US" sz="1500" dirty="0"/>
           </a:p>
@@ -7380,7 +7458,7 @@
                 <a:ea typeface="Helvetica Neue" pitchFamily="34" charset="-122"/>
                 <a:cs typeface="Helvetica Neue" pitchFamily="34" charset="-120"/>
               </a:rPr>
-              <a:t>Production infrastructure — 16 GPUs, 6 models, 31 live health probes</a:t>
+              <a:t>Production infrastructure — 6 models, 31 live health probes, 2 data center sites secured</a:t>
             </a:r>
             <a:endParaRPr lang="en-US" sz="1050" dirty="0"/>
           </a:p>

</xml_diff>

<commit_message>
Deck: full group scope (75 domains, 67M decisions, 4 verticals) — not health-only
</commit_message>
<xml_diff>
--- a/apresentacoes/ZCloud-Zai-Parceria-EN.pptx
+++ b/apresentacoes/ZCloud-Zai-Parceria-EN.pptx
@@ -5169,7 +5169,7 @@
                   <a:srgbClr val="5A6B7A"/>
                 </a:solidFill>
               </a:rPr>
-              <a:t>6 models, 31 health probes, 8 portals live, 2 data center sites secured (PB solar + CE ZPE)</a:t>
+              <a:t>75 production domains across 4 verticals · 6 frontier models · 67M+ indexed decisions · identity + compliance stack · 2 data center sites (PB solar + CE ZPE)</a:t>
             </a:r>
             <a:endParaRPr lang="en-US" sz="900" dirty="0"/>
           </a:p>
@@ -5952,7 +5952,7 @@
                   <a:srgbClr val="B0C4D4"/>
                 </a:solidFill>
               </a:rPr>
-              <a:t>Access to results.json, health.beanstech.com.br (31 live probes), private GitHub repository</a:t>
+              <a:t>Access to benchmark results (156 evaluations), health.beanstech.com.br (31 live probes), private GitHub, ragjur.ai (67M+ decisions), alirealty.com.br (production)</a:t>
             </a:r>
             <a:endParaRPr lang="en-US" sz="900" dirty="0"/>
           </a:p>
@@ -6905,7 +6905,7 @@
                 <a:ea typeface="Helvetica Neue" pitchFamily="34" charset="-122"/>
                 <a:cs typeface="Helvetica Neue" pitchFamily="34" charset="-120"/>
               </a:rPr>
-              <a:t>4</a:t>
+              <a:t>75</a:t>
             </a:r>
             <a:endParaRPr lang="en-US" sz="2200" dirty="0"/>
           </a:p>
@@ -6944,7 +6944,7 @@
                 <a:ea typeface="Helvetica Neue" pitchFamily="34" charset="-122"/>
                 <a:cs typeface="Helvetica Neue" pitchFamily="34" charset="-120"/>
               </a:rPr>
-              <a:t>Regulated Verticals</a:t>
+              <a:t>Production Domains</a:t>
             </a:r>
             <a:endParaRPr lang="en-US" sz="850" dirty="0"/>
           </a:p>
@@ -7231,7 +7231,7 @@
                   <a:srgbClr val="B0C4D4"/>
                 </a:solidFill>
               </a:rPr>
-              <a:t>What typically takes years to build (infrastructure, regulatory expertise, distribution, domains) is already operational. BeansTech runs 6 frontier models, 8 medical portals, a complete compliance stack, and has secured land for two sovereign data centers — and a clinical benchmark that validated GLM-5.3 as the top performer.</a:t>
+              <a:t>What typically takes years to build is already operational: a multi-vertical platform spanning healthcare, legal, financial, real estate and AI infrastructure — 75 production domains, 6 frontier models in production, 67M+ court decisions indexed, sovereign identity and compliance infrastructure, and secured land for two data centers (one carbon-free). A clinical benchmark independently validated GLM-5.3 as the top performer.</a:t>
             </a:r>
             <a:endParaRPr lang="en-US" sz="1500" dirty="0"/>
           </a:p>
@@ -7458,7 +7458,7 @@
                 <a:ea typeface="Helvetica Neue" pitchFamily="34" charset="-122"/>
                 <a:cs typeface="Helvetica Neue" pitchFamily="34" charset="-120"/>
               </a:rPr>
-              <a:t>Production infrastructure — 6 models, 31 live health probes, 2 data center sites secured</a:t>
+              <a:t>Full-stack platform — 75 production domains, 6 frontier models, 67M+ indexed court decisions, identity + compliance infrastructure, 2 data center sites secured</a:t>
             </a:r>
             <a:endParaRPr lang="en-US" sz="1050" dirty="0"/>
           </a:p>
@@ -13959,7 +13959,7 @@
                   <a:srgbClr val="2E6FAF"/>
                 </a:solidFill>
               </a:rPr>
-              <a:t>dodr.ai · ragmed.ai</a:t>
+              <a:t>dodr.ai · ragmed.ai (+8 portals)</a:t>
             </a:r>
             <a:endParaRPr lang="en-US" sz="1500" dirty="0"/>
           </a:p>
@@ -13999,7 +13999,7 @@
                   <a:srgbClr val="5A6B7A"/>
                 </a:solidFill>
               </a:rPr>
-              <a:t>8 portals live · 6 frontier models · anti-hallucination chain · clinical decision support</a:t>
+              <a:t>Clinical decision support · anti-hallucination chain · 6 frontier models · benchmark-validated</a:t>
             </a:r>
             <a:endParaRPr lang="en-US" sz="1500" dirty="0"/>
           </a:p>

</xml_diff>

<commit_message>
Deck: pldbr/brasileiro.tech fora; ativo.tech como commercial engine no banner do ecosystem
</commit_message>
<xml_diff>
--- a/apresentacoes/ZCloud-Zai-Parceria-EN.pptx
+++ b/apresentacoes/ZCloud-Zai-Parceria-EN.pptx
@@ -5352,7 +5352,7 @@
                   <a:srgbClr val="5A6B7A"/>
                 </a:solidFill>
               </a:rPr>
-              <a:t>Land in PB (solar+satellite) and CE (ZPE) · z.cloud, glm.cloud, ragjur.ai, ragmed.ai, dodr.ai, ativo.tech</a:t>
+              <a:t>Land in PB (solar+satellite) and CE (ZPE) · z.cloud, glm.cloud, ativo.tech, ragjur.ai, ragmed.ai, dodr.ai</a:t>
             </a:r>
             <a:endParaRPr lang="en-US" sz="900" dirty="0"/>
           </a:p>
@@ -13849,7 +13849,7 @@
                 <a:ea typeface="Helvetica Neue" pitchFamily="34" charset="-122"/>
                 <a:cs typeface="Helvetica Neue" pitchFamily="34" charset="-120"/>
               </a:rPr>
-              <a:t>75 production domains · 6 regulated verticals · shared infrastructure</a:t>
+              <a:t>75 production domains · 4 verticals + ativo.tech marketplace · shared infrastructure — one model engine upgrades all</a:t>
             </a:r>
             <a:endParaRPr lang="en-US" sz="1300" dirty="0"/>
           </a:p>
@@ -14293,7 +14293,7 @@
                   <a:srgbClr val="2E6FAF"/>
                 </a:solidFill>
               </a:rPr>
-              <a:t>beansbank · pldbr</a:t>
+              <a:t>beansbank · beans.credit</a:t>
             </a:r>
             <a:endParaRPr lang="en-US" sz="1500" dirty="0"/>
           </a:p>
@@ -14554,8 +14554,8 @@
         </p:nvSpPr>
         <p:spPr>
           <a:xfrm>
-            <a:off x="502920" y="6236208"/>
-            <a:ext cx="11183112" cy="320040"/>
+            <a:off x="502920" y="6199632"/>
+            <a:ext cx="11183112" cy="384048"/>
           </a:xfrm>
           <a:prstGeom prst="rect">
             <a:avLst/>
@@ -14571,17 +14571,17 @@
               <a:buNone/>
             </a:pPr>
             <a:r>
-              <a:rPr lang="en-US" sz="1050" b="1" dirty="0">
-                <a:solidFill>
-                  <a:srgbClr val="1A2332"/>
+              <a:rPr lang="en-US" sz="950" b="1" dirty="0">
+                <a:solidFill>
+                  <a:srgbClr val="0A1628"/>
                 </a:solidFill>
                 <a:latin typeface="Helvetica Neue" pitchFamily="34" charset="0"/>
                 <a:ea typeface="Helvetica Neue" pitchFamily="34" charset="-122"/>
                 <a:cs typeface="Helvetica Neue" pitchFamily="34" charset="-120"/>
               </a:rPr>
-              <a:t>All verticals share the same model engine — adding GLM upgrades all simultaneously.</a:t>
-            </a:r>
-            <a:endParaRPr lang="en-US" sz="1050" dirty="0"/>
+              <a:t>ativo.tech — the commercial engine: marketplace for cloud, AI, and token sales across all verticals · z.cloud as sovereign token infrastructure · one model engine (GLM) upgrades everything simultaneously</a:t>
+            </a:r>
+            <a:endParaRPr lang="en-US" sz="950" dirty="0"/>
           </a:p>
         </p:txBody>
       </p:sp>

</xml_diff>

<commit_message>
Balance: US$300M é o valor da parceria com a Z.ai especificamente — não aceitaríamos de qualquer investidor
</commit_message>
<xml_diff>
--- a/apresentacoes/ZCloud-Zai-Parceria-EN.pptx
+++ b/apresentacoes/ZCloud-Zai-Parceria-EN.pptx
@@ -5474,10 +5474,10 @@
             <a:r>
               <a:rPr lang="en-US" sz="1000" b="1" dirty="0">
                 <a:solidFill>
-                  <a:srgbClr val="0A1628"/>
-                </a:solidFill>
-              </a:rPr>
-              <a:t>On Balance: </a:t>
+                  <a:srgbClr val="C9A227"/>
+                </a:solidFill>
+              </a:rPr>
+              <a:t>On the US$ 300M: </a:t>
             </a:r>
             <a:pPr indent="0" marL="0">
               <a:lnSpc>
@@ -5491,7 +5491,7 @@
                   <a:srgbClr val="5A6B7A"/>
                 </a:solidFill>
               </a:rPr>
-              <a:t>We recognize that another company could invest more capital. What cannot be replicated at any price: regulatory expertise, production infrastructure, sovereign land, premium domains, and a clinical benchmark that independently validated GLM. The partnership is balanced because each side contributes what money alone cannot buy.</a:t>
+              <a:t>This is the value we place on this partnership — and on building it together with Z.ai specifically. It is not an amount we would accept from just any investor, regardless of size. The US$ 300M reflects what the combination of our sovereign infrastructure, regulatory expertise, and GLM’s quality is worth when built together — by partners who share the same principles. We are choosing Z.ai as much as Z.ai would be choosing us.</a:t>
             </a:r>
             <a:endParaRPr lang="en-US" sz="1000" dirty="0"/>
           </a:p>

</xml_diff>

<commit_message>
z.cloud e glm.cloud: valores reais dos domínios (1-letter premium US$250k-1M; glm.cloud owned via Alibaba DNS)
</commit_message>
<xml_diff>
--- a/apresentacoes/ZCloud-Zai-Parceria-EN.pptx
+++ b/apresentacoes/ZCloud-Zai-Parceria-EN.pptx
@@ -5352,7 +5352,7 @@
                   <a:srgbClr val="5A6B7A"/>
                 </a:solidFill>
               </a:rPr>
-              <a:t>Land in PB (solar+satellite) and CE (ZPE) · z.cloud, glm.cloud, ativo.tech, ragjur.ai, ragmed.ai, dodr.ai</a:t>
+              <a:t>Land in PB (solar+satellite) and CE (ZPE) · z.cloud (1-letter premium, est. US$ 250k–1M) · glm.cloud (3-letter, perfect for GLM-branded product) · ativo.tech · ragjur.ai · ragmed.ai · dodr.ai</a:t>
             </a:r>
             <a:endParaRPr lang="en-US" sz="900" dirty="0"/>
           </a:p>
@@ -7458,7 +7458,7 @@
                 <a:ea typeface="Helvetica Neue" pitchFamily="34" charset="-122"/>
                 <a:cs typeface="Helvetica Neue" pitchFamily="34" charset="-120"/>
               </a:rPr>
-              <a:t>Full-stack platform — 75 production domains, 6 frontier models, 67M+ indexed court decisions, identity + compliance infrastructure, 2 data center sites secured</a:t>
+              <a:t>Full-stack platform — 75 production domains (including z.cloud: 1-letter premium, live; glm.cloud: owned via Alibaba DNS) · 6 frontier models · 67M+ indexed court decisions · identity + compliance infrastructure · 2 data center sites secured</a:t>
             </a:r>
             <a:endParaRPr lang="en-US" sz="1050" dirty="0"/>
           </a:p>

</xml_diff>

<commit_message>
Revenue challenge slide (monetization gap, compute dependency, ecosystem moat); domain prices removed — irreplaceable
</commit_message>
<xml_diff>
--- a/apresentacoes/ZCloud-Zai-Parceria-EN.pptx
+++ b/apresentacoes/ZCloud-Zai-Parceria-EN.pptx
@@ -18,9 +18,10 @@
     <p:sldId id="266" r:id="rId12"/>
     <p:sldId id="267" r:id="rId13"/>
     <p:sldId id="268" r:id="rId14"/>
+    <p:sldId id="269" r:id="rId15"/>
   </p:sldIdLst>
   <p:notesMasterIdLst>
-    <p:notesMasterId r:id="rId15"/>
+    <p:notesMasterId r:id="rId16"/>
   </p:notesMasterIdLst>
   <p:sldSz cx="12188952" cy="6858000"/>
   <p:notesSz cx="6858000" cy="12188952"/>
@@ -1559,6 +1560,94 @@
             <a:fld id="{F7021451-1387-4CA6-816F-3879F97B5CBC}" type="slidenum">
               <a:rPr lang="en-US"/>
               <a:t>13</a:t>
+            </a:fld>
+            <a:endParaRPr lang="en-US"/>
+          </a:p>
+        </p:txBody>
+      </p:sp>
+    </p:spTree>
+    <p:extLst>
+      <p:ext uri="{BB962C8B-B14F-4D97-AF65-F5344CB8AC3E}">
+        <p14:creationId xmlns:p14="http://schemas.microsoft.com/office/powerpoint/2010/main" val="1024086991"/>
+      </p:ext>
+    </p:extLst>
+  </p:cSld>
+  <p:clrMapOvr>
+    <a:masterClrMapping/>
+  </p:clrMapOvr>
+</p:notes>
+</file>
+
+<file path=ppt/notesSlides/notesSlide14.xml><?xml version="1.0" encoding="utf-8"?>
+<p:notes xmlns:a="http://schemas.openxmlformats.org/drawingml/2006/main" xmlns:r="http://schemas.openxmlformats.org/officeDocument/2006/relationships" xmlns:p="http://schemas.openxmlformats.org/presentationml/2006/main">
+  <p:cSld>
+    <p:spTree>
+      <p:nvGrpSpPr>
+        <p:cNvPr id="1" name=""/>
+        <p:cNvGrpSpPr/>
+        <p:nvPr/>
+      </p:nvGrpSpPr>
+      <p:grpSpPr>
+        <a:xfrm>
+          <a:off x="0" y="0"/>
+          <a:ext cx="0" cy="0"/>
+          <a:chOff x="0" y="0"/>
+          <a:chExt cx="0" cy="0"/>
+        </a:xfrm>
+      </p:grpSpPr>
+      <p:sp>
+        <p:nvSpPr>
+          <p:cNvPr id="2" name="Slide Image Placeholder 1"/>
+          <p:cNvSpPr>
+            <a:spLocks noGrp="1" noRot="1" noChangeAspect="1"/>
+          </p:cNvSpPr>
+          <p:nvPr>
+            <p:ph type="sldImg"/>
+          </p:nvPr>
+        </p:nvSpPr>
+        <p:spPr/>
+      </p:sp>
+      <p:sp>
+        <p:nvSpPr>
+          <p:cNvPr id="3" name="Notes Placeholder 2"/>
+          <p:cNvSpPr>
+            <a:spLocks noGrp="1"/>
+          </p:cNvSpPr>
+          <p:nvPr>
+            <p:ph type="body" idx="1"/>
+          </p:nvPr>
+        </p:nvSpPr>
+        <p:spPr/>
+        <p:txBody>
+          <a:bodyPr/>
+          <a:lstStyle/>
+          <a:p>
+            <a:r>
+              <a:rPr lang="en-US" dirty="0"/>
+              <a:t/>
+            </a:r>
+            <a:endParaRPr lang="en-US" dirty="0"/>
+          </a:p>
+        </p:txBody>
+      </p:sp>
+      <p:sp>
+        <p:nvSpPr>
+          <p:cNvPr id="4" name="Slide Number Placeholder 3"/>
+          <p:cNvSpPr>
+            <a:spLocks noGrp="1"/>
+          </p:cNvSpPr>
+          <p:nvPr>
+            <p:ph type="sldNum" sz="quarter" idx="10"/>
+          </p:nvPr>
+        </p:nvSpPr>
+        <p:spPr/>
+        <p:txBody>
+          <a:bodyPr/>
+          <a:lstStyle/>
+          <a:p>
+            <a:fld id="{F7021451-1387-4CA6-816F-3879F97B5CBC}" type="slidenum">
+              <a:rPr lang="en-US"/>
+              <a:t>14</a:t>
             </a:fld>
             <a:endParaRPr lang="en-US"/>
           </a:p>
@@ -3146,6 +3235,787 @@
     <p:bg>
       <p:bgPr>
         <a:solidFill>
+          <a:srgbClr val="0A1628"/>
+        </a:solidFill>
+      </p:bgPr>
+    </p:bg>
+    <p:spTree>
+      <p:nvGrpSpPr>
+        <p:cNvPr id="1" name=""/>
+        <p:cNvGrpSpPr/>
+        <p:nvPr/>
+      </p:nvGrpSpPr>
+      <p:grpSpPr>
+        <a:xfrm>
+          <a:off x="0" y="0"/>
+          <a:ext cx="0" cy="0"/>
+          <a:chOff x="0" y="0"/>
+          <a:chExt cx="0" cy="0"/>
+        </a:xfrm>
+      </p:grpSpPr>
+      <p:sp>
+        <p:nvSpPr>
+          <p:cNvPr id="2" name="Text 0"/>
+          <p:cNvSpPr/>
+          <p:nvPr/>
+        </p:nvSpPr>
+        <p:spPr>
+          <a:xfrm>
+            <a:off x="502920" y="320040"/>
+            <a:ext cx="11183112" cy="640080"/>
+          </a:xfrm>
+          <a:prstGeom prst="rect">
+            <a:avLst/>
+          </a:prstGeom>
+          <a:noFill/>
+          <a:ln/>
+        </p:spPr>
+        <p:txBody>
+          <a:bodyPr wrap="square" lIns="0" tIns="0" rIns="0" bIns="0" rtlCol="0" anchor="ctr"/>
+          <a:lstStyle/>
+          <a:p>
+            <a:pPr indent="0" marL="0">
+              <a:buNone/>
+            </a:pPr>
+            <a:r>
+              <a:rPr lang="en-US" sz="3000" b="1" dirty="0">
+                <a:solidFill>
+                  <a:srgbClr val="E8C847"/>
+                </a:solidFill>
+                <a:latin typeface="Helvetica Neue" pitchFamily="34" charset="0"/>
+                <a:ea typeface="Helvetica Neue" pitchFamily="34" charset="-122"/>
+                <a:cs typeface="Helvetica Neue" pitchFamily="34" charset="-120"/>
+              </a:rPr>
+              <a:t>The Revenue Challenge — And How This Partnership Solves It</a:t>
+            </a:r>
+            <a:endParaRPr lang="en-US" sz="3000" dirty="0"/>
+          </a:p>
+        </p:txBody>
+      </p:sp>
+      <p:sp>
+        <p:nvSpPr>
+          <p:cNvPr id="3" name="Text 1"/>
+          <p:cNvSpPr/>
+          <p:nvPr/>
+        </p:nvSpPr>
+        <p:spPr>
+          <a:xfrm>
+            <a:off x="502920" y="914400"/>
+            <a:ext cx="11183112" cy="365760"/>
+          </a:xfrm>
+          <a:prstGeom prst="rect">
+            <a:avLst/>
+          </a:prstGeom>
+          <a:noFill/>
+          <a:ln/>
+        </p:spPr>
+        <p:txBody>
+          <a:bodyPr wrap="square" lIns="0" tIns="0" rIns="0" bIns="0" rtlCol="0" anchor="ctr"/>
+          <a:lstStyle/>
+          <a:p>
+            <a:pPr indent="0" marL="0">
+              <a:buNone/>
+            </a:pPr>
+            <a:r>
+              <a:rPr lang="en-US" sz="1300" dirty="0">
+                <a:solidFill>
+                  <a:srgbClr val="8FB0C8"/>
+                </a:solidFill>
+                <a:latin typeface="Helvetica Neue" pitchFamily="34" charset="0"/>
+                <a:ea typeface="Helvetica Neue" pitchFamily="34" charset="-122"/>
+                <a:cs typeface="Helvetica Neue" pitchFamily="34" charset="-120"/>
+              </a:rPr>
+              <a:t>Building a complete, competitive ecosystem where every participant wins</a:t>
+            </a:r>
+            <a:endParaRPr lang="en-US" sz="1300" dirty="0"/>
+          </a:p>
+        </p:txBody>
+      </p:sp>
+      <p:sp>
+        <p:nvSpPr>
+          <p:cNvPr id="4" name="Shape 2"/>
+          <p:cNvSpPr/>
+          <p:nvPr/>
+        </p:nvSpPr>
+        <p:spPr>
+          <a:xfrm>
+            <a:off x="502920" y="1298448"/>
+            <a:ext cx="2194560" cy="0"/>
+          </a:xfrm>
+          <a:prstGeom prst="line">
+            <a:avLst/>
+          </a:prstGeom>
+          <a:noFill/>
+          <a:ln w="38100">
+            <a:solidFill>
+              <a:srgbClr val="C9A227"/>
+            </a:solidFill>
+            <a:prstDash val="solid"/>
+          </a:ln>
+        </p:spPr>
+      </p:sp>
+      <p:sp>
+        <p:nvSpPr>
+          <p:cNvPr id="5" name="Text 3"/>
+          <p:cNvSpPr/>
+          <p:nvPr/>
+        </p:nvSpPr>
+        <p:spPr>
+          <a:xfrm>
+            <a:off x="502920" y="1463040"/>
+            <a:ext cx="5303520" cy="365760"/>
+          </a:xfrm>
+          <a:prstGeom prst="rect">
+            <a:avLst/>
+          </a:prstGeom>
+          <a:noFill/>
+          <a:ln/>
+        </p:spPr>
+        <p:txBody>
+          <a:bodyPr wrap="square" lIns="0" tIns="0" rIns="0" bIns="0" rtlCol="0" anchor="ctr"/>
+          <a:lstStyle/>
+          <a:p>
+            <a:pPr indent="0" marL="0">
+              <a:buNone/>
+            </a:pPr>
+            <a:r>
+              <a:rPr lang="en-US" sz="1300" b="1" dirty="0">
+                <a:solidFill>
+                  <a:srgbClr val="E8C847"/>
+                </a:solidFill>
+                <a:latin typeface="Helvetica Neue" pitchFamily="34" charset="0"/>
+                <a:ea typeface="Helvetica Neue" pitchFamily="34" charset="-122"/>
+                <a:cs typeface="Helvetica Neue" pitchFamily="34" charset="-120"/>
+              </a:rPr>
+              <a:t>The Challenge Every AI Lab Faces</a:t>
+            </a:r>
+            <a:endParaRPr lang="en-US" sz="1300" dirty="0"/>
+          </a:p>
+        </p:txBody>
+      </p:sp>
+      <p:sp>
+        <p:nvSpPr>
+          <p:cNvPr id="6" name="Text 4"/>
+          <p:cNvSpPr/>
+          <p:nvPr/>
+        </p:nvSpPr>
+        <p:spPr>
+          <a:xfrm>
+            <a:off x="502920" y="1828800"/>
+            <a:ext cx="5303520" cy="4206240"/>
+          </a:xfrm>
+          <a:prstGeom prst="rect">
+            <a:avLst/>
+          </a:prstGeom>
+          <a:noFill/>
+          <a:ln/>
+        </p:spPr>
+        <p:txBody>
+          <a:bodyPr wrap="square" lIns="0" tIns="0" rIns="0" bIns="0" rtlCol="0" anchor="ctr"/>
+          <a:lstStyle/>
+          <a:p>
+            <a:pPr marL="127000" indent="-127000">
+              <a:lnSpc>
+                <a:spcPts val="1200"/>
+              </a:lnSpc>
+              <a:spcAft>
+                <a:spcPts val="300"/>
+              </a:spcAft>
+              <a:buSzPct val="100000"/>
+              <a:buChar char="▸"/>
+            </a:pPr>
+            <a:r>
+              <a:rPr lang="en-US" b="1" dirty="0">
+                <a:solidFill>
+                  <a:srgbClr val="FFFFFF"/>
+                </a:solidFill>
+              </a:rPr>
+              <a:t>Monetization gap vs R&amp;D spend</a:t>
+            </a:r>
+            <a:endParaRPr lang="en-US" dirty="0"/>
+          </a:p>
+          <a:p>
+            <a:pPr indent="0" marL="0">
+              <a:lnSpc>
+                <a:spcPts val="1200"/>
+              </a:lnSpc>
+              <a:spcAft>
+                <a:spcPts val="300"/>
+              </a:spcAft>
+              <a:buNone/>
+            </a:pPr>
+            <a:r>
+              <a:rPr lang="en-US" sz="950" dirty="0">
+                <a:solidFill>
+                  <a:srgbClr val="B0C4D4"/>
+                </a:solidFill>
+              </a:rPr>
+              <a:t>Frontier models cost hundreds of millions to train. API revenue alone rarely covers the burn. The industry is searching for sustainable business models.</a:t>
+            </a:r>
+            <a:endParaRPr lang="en-US" sz="950" dirty="0"/>
+          </a:p>
+          <a:p>
+            <a:pPr indent="0" marL="0">
+              <a:lnSpc>
+                <a:spcPts val="1200"/>
+              </a:lnSpc>
+              <a:spcAft>
+                <a:spcPts val="300"/>
+              </a:spcAft>
+              <a:buNone/>
+            </a:pPr>
+            <a:r>
+              <a:rPr lang="en-US" sz="400" dirty="0">
+                <a:solidFill>
+                  <a:srgbClr val="000000"/>
+                </a:solidFill>
+              </a:rPr>
+              <a:t> </a:t>
+            </a:r>
+            <a:endParaRPr lang="en-US" sz="950" dirty="0"/>
+          </a:p>
+          <a:p>
+            <a:pPr marL="127000" indent="-127000">
+              <a:lnSpc>
+                <a:spcPts val="1200"/>
+              </a:lnSpc>
+              <a:spcAft>
+                <a:spcPts val="300"/>
+              </a:spcAft>
+              <a:buSzPct val="100000"/>
+              <a:buChar char="▸"/>
+            </a:pPr>
+            <a:r>
+              <a:rPr lang="en-US" sz="950" b="1" dirty="0">
+                <a:solidFill>
+                  <a:srgbClr val="FFFFFF"/>
+                </a:solidFill>
+              </a:rPr>
+              <a:t>Commoditization pressure</a:t>
+            </a:r>
+            <a:endParaRPr lang="en-US" sz="950" dirty="0"/>
+          </a:p>
+          <a:p>
+            <a:pPr indent="0" marL="0">
+              <a:lnSpc>
+                <a:spcPts val="1200"/>
+              </a:lnSpc>
+              <a:spcAft>
+                <a:spcPts val="300"/>
+              </a:spcAft>
+              <a:buNone/>
+            </a:pPr>
+            <a:r>
+              <a:rPr lang="en-US" sz="950" dirty="0">
+                <a:solidFill>
+                  <a:srgbClr val="B0C4D4"/>
+                </a:solidFill>
+              </a:rPr>
+              <a:t>Free and near-free alternatives compress API pricing. Differentiation by quality alone is not enough — you need ecosystem lock-in and switching costs.</a:t>
+            </a:r>
+            <a:endParaRPr lang="en-US" sz="950" dirty="0"/>
+          </a:p>
+          <a:p>
+            <a:pPr indent="0" marL="0">
+              <a:lnSpc>
+                <a:spcPts val="1200"/>
+              </a:lnSpc>
+              <a:spcAft>
+                <a:spcPts val="300"/>
+              </a:spcAft>
+              <a:buNone/>
+            </a:pPr>
+            <a:r>
+              <a:rPr lang="en-US" sz="400" dirty="0">
+                <a:solidFill>
+                  <a:srgbClr val="000000"/>
+                </a:solidFill>
+              </a:rPr>
+              <a:t> </a:t>
+            </a:r>
+            <a:endParaRPr lang="en-US" sz="950" dirty="0"/>
+          </a:p>
+          <a:p>
+            <a:pPr marL="127000" indent="-127000">
+              <a:lnSpc>
+                <a:spcPts val="1200"/>
+              </a:lnSpc>
+              <a:spcAft>
+                <a:spcPts val="300"/>
+              </a:spcAft>
+              <a:buSzPct val="100000"/>
+              <a:buChar char="▸"/>
+            </a:pPr>
+            <a:r>
+              <a:rPr lang="en-US" sz="950" b="1" dirty="0">
+                <a:solidFill>
+                  <a:srgbClr val="FFFFFF"/>
+                </a:solidFill>
+              </a:rPr>
+              <a:t>Geographic concentration</a:t>
+            </a:r>
+            <a:endParaRPr lang="en-US" sz="950" dirty="0"/>
+          </a:p>
+          <a:p>
+            <a:pPr indent="0" marL="0">
+              <a:lnSpc>
+                <a:spcPts val="1200"/>
+              </a:lnSpc>
+              <a:spcAft>
+                <a:spcPts val="300"/>
+              </a:spcAft>
+              <a:buNone/>
+            </a:pPr>
+            <a:r>
+              <a:rPr lang="en-US" sz="950" dirty="0">
+                <a:solidFill>
+                  <a:srgbClr val="B0C4D4"/>
+                </a:solidFill>
+              </a:rPr>
+              <a:t>Most AI revenue flows through US and Chinese markets. Latin America — 650M people, US$ 8.2B in regulated sectors — remains underserved by sovereign AI infrastructure.</a:t>
+            </a:r>
+            <a:endParaRPr lang="en-US" sz="950" dirty="0"/>
+          </a:p>
+          <a:p>
+            <a:pPr indent="0" marL="0">
+              <a:lnSpc>
+                <a:spcPts val="1200"/>
+              </a:lnSpc>
+              <a:spcAft>
+                <a:spcPts val="300"/>
+              </a:spcAft>
+              <a:buNone/>
+            </a:pPr>
+            <a:r>
+              <a:rPr lang="en-US" sz="400" dirty="0">
+                <a:solidFill>
+                  <a:srgbClr val="000000"/>
+                </a:solidFill>
+              </a:rPr>
+              <a:t> </a:t>
+            </a:r>
+            <a:endParaRPr lang="en-US" sz="950" dirty="0"/>
+          </a:p>
+          <a:p>
+            <a:pPr marL="127000" indent="-127000">
+              <a:lnSpc>
+                <a:spcPts val="1200"/>
+              </a:lnSpc>
+              <a:spcAft>
+                <a:spcPts val="300"/>
+              </a:spcAft>
+              <a:buSzPct val="100000"/>
+              <a:buChar char="▸"/>
+            </a:pPr>
+            <a:r>
+              <a:rPr lang="en-US" sz="950" b="1" dirty="0">
+                <a:solidFill>
+                  <a:srgbClr val="FFFFFF"/>
+                </a:solidFill>
+              </a:rPr>
+              <a:t>Compute dependency</a:t>
+            </a:r>
+            <a:endParaRPr lang="en-US" sz="950" dirty="0"/>
+          </a:p>
+          <a:p>
+            <a:pPr indent="0" marL="0">
+              <a:lnSpc>
+                <a:spcPts val="1200"/>
+              </a:lnSpc>
+              <a:spcAft>
+                <a:spcPts val="300"/>
+              </a:spcAft>
+              <a:buNone/>
+            </a:pPr>
+            <a:r>
+              <a:rPr lang="en-US" sz="950" dirty="0">
+                <a:solidFill>
+                  <a:srgbClr val="B0C4D4"/>
+                </a:solidFill>
+              </a:rPr>
+              <a:t>Running at the mercy of cloud provider GPU allocation creates a growth ceiling — and a cost structure that eats margins.</a:t>
+            </a:r>
+            <a:endParaRPr lang="en-US" sz="950" dirty="0"/>
+          </a:p>
+        </p:txBody>
+      </p:sp>
+      <p:sp>
+        <p:nvSpPr>
+          <p:cNvPr id="7" name="Text 5"/>
+          <p:cNvSpPr/>
+          <p:nvPr/>
+        </p:nvSpPr>
+        <p:spPr>
+          <a:xfrm>
+            <a:off x="6400800" y="1463040"/>
+            <a:ext cx="5303520" cy="365760"/>
+          </a:xfrm>
+          <a:prstGeom prst="rect">
+            <a:avLst/>
+          </a:prstGeom>
+          <a:noFill/>
+          <a:ln/>
+        </p:spPr>
+        <p:txBody>
+          <a:bodyPr wrap="square" lIns="0" tIns="0" rIns="0" bIns="0" rtlCol="0" anchor="ctr"/>
+          <a:lstStyle/>
+          <a:p>
+            <a:pPr indent="0" marL="0">
+              <a:buNone/>
+            </a:pPr>
+            <a:r>
+              <a:rPr lang="en-US" sz="1300" b="1" dirty="0">
+                <a:solidFill>
+                  <a:srgbClr val="E8C847"/>
+                </a:solidFill>
+                <a:latin typeface="Helvetica Neue" pitchFamily="34" charset="0"/>
+                <a:ea typeface="Helvetica Neue" pitchFamily="34" charset="-122"/>
+                <a:cs typeface="Helvetica Neue" pitchFamily="34" charset="-120"/>
+              </a:rPr>
+              <a:t>How This Partnership Answers Each One</a:t>
+            </a:r>
+            <a:endParaRPr lang="en-US" sz="1300" dirty="0"/>
+          </a:p>
+        </p:txBody>
+      </p:sp>
+      <p:sp>
+        <p:nvSpPr>
+          <p:cNvPr id="8" name="Text 6"/>
+          <p:cNvSpPr/>
+          <p:nvPr/>
+        </p:nvSpPr>
+        <p:spPr>
+          <a:xfrm>
+            <a:off x="6400800" y="1828800"/>
+            <a:ext cx="5303520" cy="4206240"/>
+          </a:xfrm>
+          <a:prstGeom prst="rect">
+            <a:avLst/>
+          </a:prstGeom>
+          <a:noFill/>
+          <a:ln/>
+        </p:spPr>
+        <p:txBody>
+          <a:bodyPr wrap="square" lIns="0" tIns="0" rIns="0" bIns="0" rtlCol="0" anchor="ctr"/>
+          <a:lstStyle/>
+          <a:p>
+            <a:pPr marL="127000" indent="-127000">
+              <a:lnSpc>
+                <a:spcPts val="1200"/>
+              </a:lnSpc>
+              <a:spcAft>
+                <a:spcPts val="300"/>
+              </a:spcAft>
+              <a:buSzPct val="100000"/>
+              <a:buChar char="▸"/>
+            </a:pPr>
+            <a:r>
+              <a:rPr lang="en-US" b="1" dirty="0">
+                <a:solidFill>
+                  <a:srgbClr val="E8C847"/>
+                </a:solidFill>
+              </a:rPr>
+              <a:t>Ecosystem, not just API</a:t>
+            </a:r>
+            <a:endParaRPr lang="en-US" dirty="0"/>
+          </a:p>
+          <a:p>
+            <a:pPr indent="0" marL="0">
+              <a:lnSpc>
+                <a:spcPts val="1200"/>
+              </a:lnSpc>
+              <a:spcAft>
+                <a:spcPts val="300"/>
+              </a:spcAft>
+              <a:buNone/>
+            </a:pPr>
+            <a:r>
+              <a:rPr lang="en-US" sz="950" dirty="0">
+                <a:solidFill>
+                  <a:srgbClr val="B0C4D4"/>
+                </a:solidFill>
+              </a:rPr>
+              <a:t>The partnership is not a reseller agreement. It is a joint venture that builds a complete ecosystem: model + infrastructure + identity + compliance + distribution + marketplace. Every layer creates switching costs and recurring revenue.</a:t>
+            </a:r>
+            <a:endParaRPr lang="en-US" sz="950" dirty="0"/>
+          </a:p>
+          <a:p>
+            <a:pPr indent="0" marL="0">
+              <a:lnSpc>
+                <a:spcPts val="1200"/>
+              </a:lnSpc>
+              <a:spcAft>
+                <a:spcPts val="300"/>
+              </a:spcAft>
+              <a:buNone/>
+            </a:pPr>
+            <a:r>
+              <a:rPr lang="en-US" sz="400" dirty="0">
+                <a:solidFill>
+                  <a:srgbClr val="000000"/>
+                </a:solidFill>
+              </a:rPr>
+              <a:t> </a:t>
+            </a:r>
+            <a:endParaRPr lang="en-US" sz="950" dirty="0"/>
+          </a:p>
+          <a:p>
+            <a:pPr marL="127000" indent="-127000">
+              <a:lnSpc>
+                <a:spcPts val="1200"/>
+              </a:lnSpc>
+              <a:spcAft>
+                <a:spcPts val="300"/>
+              </a:spcAft>
+              <a:buSzPct val="100000"/>
+              <a:buChar char="▸"/>
+            </a:pPr>
+            <a:r>
+              <a:rPr lang="en-US" sz="950" b="1" dirty="0">
+                <a:solidFill>
+                  <a:srgbClr val="E8C847"/>
+                </a:solidFill>
+              </a:rPr>
+              <a:t>Sovereign infrastructure = zero compute dependency</a:t>
+            </a:r>
+            <a:endParaRPr lang="en-US" sz="950" dirty="0"/>
+          </a:p>
+          <a:p>
+            <a:pPr indent="0" marL="0">
+              <a:lnSpc>
+                <a:spcPts val="1200"/>
+              </a:lnSpc>
+              <a:spcAft>
+                <a:spcPts val="300"/>
+              </a:spcAft>
+              <a:buNone/>
+            </a:pPr>
+            <a:r>
+              <a:rPr lang="en-US" sz="950" dirty="0">
+                <a:solidFill>
+                  <a:srgbClr val="B0C4D4"/>
+                </a:solidFill>
+              </a:rPr>
+              <a:t>The data centers solve the compute problem that constrains every AI company today. Owning sovereign GPU infrastructure with near-zero marginal energy cost means scaling to demand, not to third-party allocation. Every GPU-hour served becomes revenue, not cost.</a:t>
+            </a:r>
+            <a:endParaRPr lang="en-US" sz="950" dirty="0"/>
+          </a:p>
+          <a:p>
+            <a:pPr indent="0" marL="0">
+              <a:lnSpc>
+                <a:spcPts val="1200"/>
+              </a:lnSpc>
+              <a:spcAft>
+                <a:spcPts val="300"/>
+              </a:spcAft>
+              <a:buNone/>
+            </a:pPr>
+            <a:r>
+              <a:rPr lang="en-US" sz="400" dirty="0">
+                <a:solidFill>
+                  <a:srgbClr val="000000"/>
+                </a:solidFill>
+              </a:rPr>
+              <a:t> </a:t>
+            </a:r>
+            <a:endParaRPr lang="en-US" sz="950" dirty="0"/>
+          </a:p>
+          <a:p>
+            <a:pPr marL="127000" indent="-127000">
+              <a:lnSpc>
+                <a:spcPts val="1200"/>
+              </a:lnSpc>
+              <a:spcAft>
+                <a:spcPts val="300"/>
+              </a:spcAft>
+              <a:buSzPct val="100000"/>
+              <a:buChar char="▸"/>
+            </a:pPr>
+            <a:r>
+              <a:rPr lang="en-US" sz="950" b="1" dirty="0">
+                <a:solidFill>
+                  <a:srgbClr val="E8C847"/>
+                </a:solidFill>
+              </a:rPr>
+              <a:t>Regulated markets = premium pricing</a:t>
+            </a:r>
+            <a:endParaRPr lang="en-US" sz="950" dirty="0"/>
+          </a:p>
+          <a:p>
+            <a:pPr indent="0" marL="0">
+              <a:lnSpc>
+                <a:spcPts val="1200"/>
+              </a:lnSpc>
+              <a:spcAft>
+                <a:spcPts val="300"/>
+              </a:spcAft>
+              <a:buNone/>
+            </a:pPr>
+            <a:r>
+              <a:rPr lang="en-US" sz="950" dirty="0">
+                <a:solidFill>
+                  <a:srgbClr val="B0C4D4"/>
+                </a:solidFill>
+              </a:rPr>
+              <a:t>Healthcare, legal, and financial institutions pay for trust, not tokens. In sectors where a wrong answer has clinical or legal consequences, the premium is on auditability and abstinence — not on speed. GLM-5.3’s ethical behavior becomes a pricing moat.</a:t>
+            </a:r>
+            <a:endParaRPr lang="en-US" sz="950" dirty="0"/>
+          </a:p>
+          <a:p>
+            <a:pPr indent="0" marL="0">
+              <a:lnSpc>
+                <a:spcPts val="1200"/>
+              </a:lnSpc>
+              <a:spcAft>
+                <a:spcPts val="300"/>
+              </a:spcAft>
+              <a:buNone/>
+            </a:pPr>
+            <a:r>
+              <a:rPr lang="en-US" sz="400" dirty="0">
+                <a:solidFill>
+                  <a:srgbClr val="000000"/>
+                </a:solidFill>
+              </a:rPr>
+              <a:t> </a:t>
+            </a:r>
+            <a:endParaRPr lang="en-US" sz="950" dirty="0"/>
+          </a:p>
+          <a:p>
+            <a:pPr marL="127000" indent="-127000">
+              <a:lnSpc>
+                <a:spcPts val="1200"/>
+              </a:lnSpc>
+              <a:spcAft>
+                <a:spcPts val="300"/>
+              </a:spcAft>
+              <a:buSzPct val="100000"/>
+              <a:buChar char="▸"/>
+            </a:pPr>
+            <a:r>
+              <a:rPr lang="en-US" sz="950" b="1" dirty="0">
+                <a:solidFill>
+                  <a:srgbClr val="E8C847"/>
+                </a:solidFill>
+              </a:rPr>
+              <a:t>LATAM = uncontested market</a:t>
+            </a:r>
+            <a:endParaRPr lang="en-US" sz="950" dirty="0"/>
+          </a:p>
+          <a:p>
+            <a:pPr indent="0" marL="0">
+              <a:lnSpc>
+                <a:spcPts val="1200"/>
+              </a:lnSpc>
+              <a:spcAft>
+                <a:spcPts val="300"/>
+              </a:spcAft>
+              <a:buNone/>
+            </a:pPr>
+            <a:r>
+              <a:rPr lang="en-US" sz="950" dirty="0">
+                <a:solidFill>
+                  <a:srgbClr val="B0C4D4"/>
+                </a:solidFill>
+              </a:rPr>
+              <a:t>No other AI provider offers sovereign, regulated-market infrastructure in Latin America. First mover advantage in a 650M-person market with US$ 8.2B in addressable regulated spend.</a:t>
+            </a:r>
+            <a:endParaRPr lang="en-US" sz="950" dirty="0"/>
+          </a:p>
+        </p:txBody>
+      </p:sp>
+      <p:sp>
+        <p:nvSpPr>
+          <p:cNvPr id="9" name="Text 7"/>
+          <p:cNvSpPr/>
+          <p:nvPr/>
+        </p:nvSpPr>
+        <p:spPr>
+          <a:xfrm>
+            <a:off x="502920" y="6510528"/>
+            <a:ext cx="5486400" cy="256032"/>
+          </a:xfrm>
+          <a:prstGeom prst="rect">
+            <a:avLst/>
+          </a:prstGeom>
+          <a:noFill/>
+          <a:ln/>
+        </p:spPr>
+        <p:txBody>
+          <a:bodyPr wrap="square" lIns="0" tIns="0" rIns="0" bIns="0" rtlCol="0" anchor="ctr"/>
+          <a:lstStyle/>
+          <a:p>
+            <a:pPr indent="0" marL="0">
+              <a:buNone/>
+            </a:pPr>
+            <a:r>
+              <a:rPr lang="en-US" sz="800" dirty="0">
+                <a:solidFill>
+                  <a:srgbClr val="6B8BB0"/>
+                </a:solidFill>
+                <a:latin typeface="Helvetica Neue" pitchFamily="34" charset="0"/>
+                <a:ea typeface="Helvetica Neue" pitchFamily="34" charset="-122"/>
+                <a:cs typeface="Helvetica Neue" pitchFamily="34" charset="-120"/>
+              </a:rPr>
+              <a:t>BeansTech × Z.ai — Confidential</a:t>
+            </a:r>
+            <a:endParaRPr lang="en-US" sz="800" dirty="0"/>
+          </a:p>
+        </p:txBody>
+      </p:sp>
+      <p:sp>
+        <p:nvSpPr>
+          <p:cNvPr id="10" name="Text 8"/>
+          <p:cNvSpPr/>
+          <p:nvPr/>
+        </p:nvSpPr>
+        <p:spPr>
+          <a:xfrm>
+            <a:off x="11228832" y="6510528"/>
+            <a:ext cx="457200" cy="256032"/>
+          </a:xfrm>
+          <a:prstGeom prst="rect">
+            <a:avLst/>
+          </a:prstGeom>
+          <a:noFill/>
+          <a:ln/>
+        </p:spPr>
+        <p:txBody>
+          <a:bodyPr wrap="square" lIns="0" tIns="0" rIns="0" bIns="0" rtlCol="0" anchor="ctr"/>
+          <a:lstStyle/>
+          <a:p>
+            <a:pPr algn="r" indent="0" marL="0">
+              <a:buNone/>
+            </a:pPr>
+            <a:r>
+              <a:rPr lang="en-US" sz="800" dirty="0">
+                <a:solidFill>
+                  <a:srgbClr val="6B8BB0"/>
+                </a:solidFill>
+                <a:latin typeface="Helvetica Neue" pitchFamily="34" charset="0"/>
+                <a:ea typeface="Helvetica Neue" pitchFamily="34" charset="-122"/>
+                <a:cs typeface="Helvetica Neue" pitchFamily="34" charset="-120"/>
+              </a:rPr>
+              <a:t>10</a:t>
+            </a:r>
+            <a:endParaRPr lang="en-US" sz="800" dirty="0"/>
+          </a:p>
+        </p:txBody>
+      </p:sp>
+    </p:spTree>
+  </p:cSld>
+  <p:clrMapOvr>
+    <a:masterClrMapping/>
+  </p:clrMapOvr>
+</p:sld>
+</file>
+
+<file path=ppt/slides/slide11.xml><?xml version="1.0" encoding="utf-8"?>
+<p:sld xmlns:a="http://schemas.openxmlformats.org/drawingml/2006/main" xmlns:r="http://schemas.openxmlformats.org/officeDocument/2006/relationships" xmlns:p="http://schemas.openxmlformats.org/presentationml/2006/main">
+  <p:cSld name="Slide 11">
+    <p:bg>
+      <p:bgPr>
+        <a:solidFill>
           <a:srgbClr val="FFFFFF"/>
         </a:solidFill>
       </p:bgPr>
@@ -3982,7 +4852,7 @@
                 <a:ea typeface="Helvetica Neue" pitchFamily="34" charset="-122"/>
                 <a:cs typeface="Helvetica Neue" pitchFamily="34" charset="-120"/>
               </a:rPr>
-              <a:t>10</a:t>
+              <a:t>11</a:t>
             </a:r>
             <a:endParaRPr lang="en-US" sz="800" dirty="0"/>
           </a:p>
@@ -3996,9 +4866,9 @@
 </p:sld>
 </file>
 
-<file path=ppt/slides/slide11.xml><?xml version="1.0" encoding="utf-8"?>
+<file path=ppt/slides/slide12.xml><?xml version="1.0" encoding="utf-8"?>
 <p:sld xmlns:a="http://schemas.openxmlformats.org/drawingml/2006/main" xmlns:r="http://schemas.openxmlformats.org/officeDocument/2006/relationships" xmlns:p="http://schemas.openxmlformats.org/presentationml/2006/main">
-  <p:cSld name="Slide 11">
+  <p:cSld name="Slide 12">
     <p:bg>
       <p:bgPr>
         <a:solidFill>
@@ -4619,7 +5489,7 @@
                 <a:ea typeface="Helvetica Neue" pitchFamily="34" charset="-122"/>
                 <a:cs typeface="Helvetica Neue" pitchFamily="34" charset="-120"/>
               </a:rPr>
-              <a:t>11</a:t>
+              <a:t>12</a:t>
             </a:r>
             <a:endParaRPr lang="en-US" sz="800" dirty="0"/>
           </a:p>
@@ -4633,9 +5503,9 @@
 </p:sld>
 </file>
 
-<file path=ppt/slides/slide12.xml><?xml version="1.0" encoding="utf-8"?>
+<file path=ppt/slides/slide13.xml><?xml version="1.0" encoding="utf-8"?>
 <p:sld xmlns:a="http://schemas.openxmlformats.org/drawingml/2006/main" xmlns:r="http://schemas.openxmlformats.org/officeDocument/2006/relationships" xmlns:p="http://schemas.openxmlformats.org/presentationml/2006/main">
-  <p:cSld name="Slide 12">
+  <p:cSld name="Slide 13">
     <p:bg>
       <p:bgPr>
         <a:solidFill>
@@ -5352,7 +6222,7 @@
                   <a:srgbClr val="5A6B7A"/>
                 </a:solidFill>
               </a:rPr>
-              <a:t>Land in PB (solar+satellite) and CE (ZPE) · z.cloud (1-letter premium, est. US$ 250k–1M) · glm.cloud (3-letter, perfect for GLM-branded product) · ativo.tech · ragjur.ai · ragmed.ai · dodr.ai</a:t>
+              <a:t>Land in PB (solar+satellite) and CE (ZPE) · z.cloud (1-letter premium, live, irreplaceable) · glm.cloud (GLM-branded product domain, owned and ready) · ativo.tech · ragjur.ai · ragmed.ai · dodr.ai</a:t>
             </a:r>
             <a:endParaRPr lang="en-US" sz="900" dirty="0"/>
           </a:p>
@@ -5569,7 +6439,7 @@
                 <a:ea typeface="Helvetica Neue" pitchFamily="34" charset="-122"/>
                 <a:cs typeface="Helvetica Neue" pitchFamily="34" charset="-120"/>
               </a:rPr>
-              <a:t>12</a:t>
+              <a:t>13</a:t>
             </a:r>
             <a:endParaRPr lang="en-US" sz="800" dirty="0"/>
           </a:p>
@@ -5583,9 +6453,9 @@
 </p:sld>
 </file>
 
-<file path=ppt/slides/slide13.xml><?xml version="1.0" encoding="utf-8"?>
+<file path=ppt/slides/slide14.xml><?xml version="1.0" encoding="utf-8"?>
 <p:sld xmlns:a="http://schemas.openxmlformats.org/drawingml/2006/main" xmlns:r="http://schemas.openxmlformats.org/officeDocument/2006/relationships" xmlns:p="http://schemas.openxmlformats.org/presentationml/2006/main">
-  <p:cSld name="Slide 13">
+  <p:cSld name="Slide 14">
     <p:bg>
       <p:bgPr>
         <a:solidFill>
@@ -6502,7 +7372,7 @@
                 <a:ea typeface="Helvetica Neue" pitchFamily="34" charset="-122"/>
                 <a:cs typeface="Helvetica Neue" pitchFamily="34" charset="-120"/>
               </a:rPr>
-              <a:t>13</a:t>
+              <a:t>14</a:t>
             </a:r>
             <a:endParaRPr lang="en-US" sz="800" dirty="0"/>
           </a:p>
@@ -7458,7 +8328,7 @@
                 <a:ea typeface="Helvetica Neue" pitchFamily="34" charset="-122"/>
                 <a:cs typeface="Helvetica Neue" pitchFamily="34" charset="-120"/>
               </a:rPr>
-              <a:t>Full-stack platform — 75 production domains (including z.cloud: 1-letter premium, live; glm.cloud: owned via Alibaba DNS) · 6 frontier models · 67M+ indexed court decisions · identity + compliance infrastructure · 2 data center sites secured</a:t>
+              <a:t>Full-stack platform — 75 production domains (z.cloud and glm.cloud: irreplaceable brand assets, live and owned) · 6 frontier models · 67M+ indexed court decisions · identity + compliance infrastructure · 2 data center sites secured</a:t>
             </a:r>
             <a:endParaRPr lang="en-US" sz="1050" dirty="0"/>
           </a:p>

</xml_diff>

<commit_message>
Fix slide 7 footer overlap
</commit_message>
<xml_diff>
--- a/apresentacoes/ZCloud-Zai-Parceria-EN.pptx
+++ b/apresentacoes/ZCloud-Zai-Parceria-EN.pptx
@@ -15424,8 +15424,8 @@
         </p:nvSpPr>
         <p:spPr>
           <a:xfrm>
-            <a:off x="502920" y="6199632"/>
-            <a:ext cx="11183112" cy="384048"/>
+            <a:off x="502920" y="6108192"/>
+            <a:ext cx="11183112" cy="347472"/>
           </a:xfrm>
           <a:prstGeom prst="rect">
             <a:avLst/>
@@ -15441,7 +15441,7 @@
               <a:buNone/>
             </a:pPr>
             <a:r>
-              <a:rPr lang="en-US" sz="950" b="1" dirty="0">
+              <a:rPr lang="en-US" sz="900" b="1" dirty="0">
                 <a:solidFill>
                   <a:srgbClr val="0A1628"/>
                 </a:solidFill>
@@ -15451,7 +15451,7 @@
               </a:rPr>
               <a:t>ativo.tech — the commercial engine: marketplace for cloud, AI, and token sales across all verticals · z.cloud as sovereign token infrastructure · one model engine (GLM) upgrades everything simultaneously</a:t>
             </a:r>
-            <a:endParaRPr lang="en-US" sz="950" dirty="0"/>
+            <a:endParaRPr lang="en-US" sz="900" dirty="0"/>
           </a:p>
         </p:txBody>
       </p:sp>

</xml_diff>

<commit_message>
67M→77M court decisions (correção)
</commit_message>
<xml_diff>
--- a/apresentacoes/ZCloud-Zai-Parceria-EN.pptx
+++ b/apresentacoes/ZCloud-Zai-Parceria-EN.pptx
@@ -5411,7 +5411,7 @@
                   <a:srgbClr val="B0C4D4"/>
                 </a:solidFill>
               </a:rPr>
-              <a:t>Matheus Ximenes — Attorney, 12 years in the Brazilian Judiciary (7 as legal advisor to a Supreme Court Minister). Postgraduate in Cloud Computing and Data Protection. Creator of ragjur.ai (67M+ decisions) and ragmed.ai. Owner of z.cloud and glm.cloud.</a:t>
+              <a:t>Matheus Ximenes — Attorney, 12 years in the Brazilian Judiciary (7 as legal advisor to a Supreme Court Minister). Postgraduate in Cloud Computing and Data Protection. Creator of ragjur.ai (77M+ decisions) and ragmed.ai. Owner of z.cloud and glm.cloud.</a:t>
             </a:r>
             <a:endParaRPr lang="en-US" sz="1000" dirty="0"/>
           </a:p>
@@ -6039,7 +6039,7 @@
                   <a:srgbClr val="5A6B7A"/>
                 </a:solidFill>
               </a:rPr>
-              <a:t>75 production domains across 4 verticals · 6 frontier models · 67M+ indexed decisions · identity + compliance stack · 2 data center sites (PB solar + CE ZPE)</a:t>
+              <a:t>75 production domains across 4 verticals · 6 frontier models · 77M+ indexed decisions · identity + compliance stack · 2 data center sites (PB solar + CE ZPE)</a:t>
             </a:r>
             <a:endParaRPr lang="en-US" sz="900" dirty="0"/>
           </a:p>
@@ -6822,7 +6822,7 @@
                   <a:srgbClr val="B0C4D4"/>
                 </a:solidFill>
               </a:rPr>
-              <a:t>Access to benchmark results (156 evaluations), health.beanstech.com.br (31 live probes), private GitHub, ragjur.ai (67M+ decisions), alirealty.com.br (production)</a:t>
+              <a:t>Access to benchmark results (156 evaluations), health.beanstech.com.br (31 live probes), private GitHub, ragjur.ai (77M+ decisions), alirealty.com.br (production)</a:t>
             </a:r>
             <a:endParaRPr lang="en-US" sz="900" dirty="0"/>
           </a:p>
@@ -8101,7 +8101,7 @@
                   <a:srgbClr val="B0C4D4"/>
                 </a:solidFill>
               </a:rPr>
-              <a:t>What typically takes years to build is already operational: a multi-vertical platform spanning healthcare, legal, financial, real estate and AI infrastructure — 75 production domains, 6 frontier models in production, 67M+ court decisions indexed, sovereign identity and compliance infrastructure, and secured land for two data centers (one carbon-free). A clinical benchmark independently validated GLM-5.3 as the top performer.</a:t>
+              <a:t>What typically takes years to build is already operational: a multi-vertical platform spanning healthcare, legal, financial, real estate and AI infrastructure — 75 production domains, 6 frontier models in production, 77M+ court decisions indexed, sovereign identity and compliance infrastructure, and secured land for two data centers (one carbon-free). A clinical benchmark independently validated GLM-5.3 as the top performer.</a:t>
             </a:r>
             <a:endParaRPr lang="en-US" sz="1500" dirty="0"/>
           </a:p>
@@ -8328,7 +8328,7 @@
                 <a:ea typeface="Helvetica Neue" pitchFamily="34" charset="-122"/>
                 <a:cs typeface="Helvetica Neue" pitchFamily="34" charset="-120"/>
               </a:rPr>
-              <a:t>Full-stack platform — 75 production domains (z.cloud and glm.cloud: irreplaceable brand assets, live and owned) · 6 frontier models · 67M+ indexed court decisions · identity + compliance infrastructure · 2 data center sites secured</a:t>
+              <a:t>Full-stack platform — 75 production domains (z.cloud and glm.cloud: irreplaceable brand assets, live and owned) · 6 frontier models · 77M+ indexed court decisions · identity + compliance infrastructure · 2 data center sites secured</a:t>
             </a:r>
             <a:endParaRPr lang="en-US" sz="1050" dirty="0"/>
           </a:p>
@@ -15036,7 +15036,7 @@
                   <a:srgbClr val="5A6B7A"/>
                 </a:solidFill>
               </a:rPr>
-              <a:t>67M+ court decisions indexed · 55 sources · GLM-5.3 for analysis, Flash for volume search</a:t>
+              <a:t>77M+ court decisions indexed · 55 sources · GLM-5.3 for analysis, Flash for volume search</a:t>
             </a:r>
             <a:endParaRPr lang="en-US" sz="1500" dirty="0"/>
           </a:p>

</xml_diff>

<commit_message>
proptechbr.ai + pldbr.tech adicionados; z.cloud ownership sutil; 5 verticals
</commit_message>
<xml_diff>
--- a/apresentacoes/ZCloud-Zai-Parceria-EN.pptx
+++ b/apresentacoes/ZCloud-Zai-Parceria-EN.pptx
@@ -6222,7 +6222,7 @@
                   <a:srgbClr val="5A6B7A"/>
                 </a:solidFill>
               </a:rPr>
-              <a:t>Land in PB (solar+satellite) and CE (ZPE) · z.cloud (1-letter premium, live, irreplaceable) · glm.cloud (GLM-branded product domain, owned and ready) · ativo.tech · ragjur.ai · ragmed.ai · dodr.ai</a:t>
+              <a:t>Land in PB (solar+satellite) and CE (ZPE) · z.cloud (1-letter premium, live, irreplaceable) · glm.cloud (GLM-branded product domain, owned and ready) · ativo.tech · ragjur.ai · ragmed.ai · dodr.ai · proptechbr.ai · pldbr.tech</a:t>
             </a:r>
             <a:endParaRPr lang="en-US" sz="900" dirty="0"/>
           </a:p>
@@ -7775,7 +7775,7 @@
                 <a:ea typeface="Helvetica Neue" pitchFamily="34" charset="-122"/>
                 <a:cs typeface="Helvetica Neue" pitchFamily="34" charset="-120"/>
               </a:rPr>
-              <a:t>75</a:t>
+              <a:t>75+</a:t>
             </a:r>
             <a:endParaRPr lang="en-US" sz="2200" dirty="0"/>
           </a:p>
@@ -8101,7 +8101,7 @@
                   <a:srgbClr val="B0C4D4"/>
                 </a:solidFill>
               </a:rPr>
-              <a:t>What typically takes years to build is already operational: a multi-vertical platform spanning healthcare, legal, financial, real estate and AI infrastructure — 75 production domains, 6 frontier models in production, 77M+ court decisions indexed, sovereign identity and compliance infrastructure, and secured land for two data centers (one carbon-free). A clinical benchmark independently validated GLM-5.3 as the top performer.</a:t>
+              <a:t>What typically takes years to build is already operational: a multi-vertical platform spanning healthcare, legal, financial, real estate, compliance and AI infrastructure — 75 production domains, 6 frontier models in production, 77M+ court decisions indexed, sovereign identity and compliance infrastructure, and secured land for two data centers (one carbon-free). A clinical benchmark independently validated GLM-5.3 as the top performer.</a:t>
             </a:r>
             <a:endParaRPr lang="en-US" sz="1500" dirty="0"/>
           </a:p>
@@ -11548,7 +11548,7 @@
                   <a:srgbClr val="E8C847"/>
                 </a:solidFill>
               </a:rPr>
-              <a:t>With GLM on z.cloud, the answer is: "In Brazilian territory, with complete audit trail, transparent abstention, and a frontier-quality model."</a:t>
+              <a:t>With GLM on z.cloud — a domain we own, a platform we built, a promise we are ready to fulfill — the answer is: "In Brazilian territory, with complete audit trail, transparent abstention, and a frontier-quality model."</a:t>
             </a:r>
             <a:endParaRPr lang="en-US" sz="1600" dirty="0"/>
           </a:p>
@@ -15330,7 +15330,7 @@
                   <a:srgbClr val="8FB0C8"/>
                 </a:solidFill>
               </a:rPr>
-              <a:t>alirealty.com.br · cyrela.ai</a:t>
+              <a:t>proptechbr.ai · alirealty.com.br · cyrela.ai</a:t>
             </a:r>
             <a:endParaRPr lang="en-US" sz="1500" dirty="0"/>
           </a:p>
@@ -15370,7 +15370,7 @@
                   <a:srgbClr val="B0C4D4"/>
                 </a:solidFill>
               </a:rPr>
-              <a:t>Document analysis, credit triage, due diligence · GLM-5.3 Flash processes in seconds what takes hours</a:t>
+              <a:t>Document analysis, credit triage, due diligence · proptechbr.ai as the vertical’s entry point and flagship AI portal</a:t>
             </a:r>
             <a:endParaRPr lang="en-US" sz="1500" dirty="0"/>
           </a:p>

</xml_diff>